<commit_message>
Mejora las diapositivas: logo real de la marca y mas pulido visual
</commit_message>
<xml_diff>
--- a/docs/slides.pptx
+++ b/docs/slides.pptx
@@ -3140,14 +3140,126 @@
       </p:sp>
       <p:sp>
         <p:nvSpPr>
-          <p:cNvPr id="3" name="TextBox 2"/>
+          <p:cNvPr id="3" name="Oval 2"/>
+          <p:cNvSpPr/>
+          <p:nvPr/>
+        </p:nvSpPr>
+        <p:spPr>
+          <a:xfrm>
+            <a:off x="-2743200" y="-2743200"/>
+            <a:ext cx="8229600" cy="8229600"/>
+          </a:xfrm>
+          <a:prstGeom prst="ellipse">
+            <a:avLst/>
+          </a:prstGeom>
+          <a:solidFill>
+            <a:srgbClr val="142B42"/>
+          </a:solidFill>
+          <a:ln>
+            <a:noFill/>
+          </a:ln>
+          <a:effectLst/>
+        </p:spPr>
+        <p:style>
+          <a:lnRef idx="1">
+            <a:schemeClr val="accent1"/>
+          </a:lnRef>
+          <a:fillRef idx="3">
+            <a:schemeClr val="accent1"/>
+          </a:fillRef>
+          <a:effectRef idx="2">
+            <a:schemeClr val="accent1"/>
+          </a:effectRef>
+          <a:fontRef idx="minor">
+            <a:schemeClr val="lt1"/>
+          </a:fontRef>
+        </p:style>
+        <p:txBody>
+          <a:bodyPr rtlCol="0" anchor="ctr"/>
+          <a:lstStyle/>
+          <a:p>
+            <a:pPr algn="ctr"/>
+          </a:p>
+        </p:txBody>
+      </p:sp>
+      <p:sp>
+        <p:nvSpPr>
+          <p:cNvPr id="4" name="Oval 3"/>
+          <p:cNvSpPr/>
+          <p:nvPr/>
+        </p:nvSpPr>
+        <p:spPr>
+          <a:xfrm>
+            <a:off x="9601200" y="4114800"/>
+            <a:ext cx="5486400" cy="5486400"/>
+          </a:xfrm>
+          <a:prstGeom prst="ellipse">
+            <a:avLst/>
+          </a:prstGeom>
+          <a:solidFill>
+            <a:srgbClr val="142B42"/>
+          </a:solidFill>
+          <a:ln>
+            <a:noFill/>
+          </a:ln>
+          <a:effectLst/>
+        </p:spPr>
+        <p:style>
+          <a:lnRef idx="1">
+            <a:schemeClr val="accent1"/>
+          </a:lnRef>
+          <a:fillRef idx="3">
+            <a:schemeClr val="accent1"/>
+          </a:fillRef>
+          <a:effectRef idx="2">
+            <a:schemeClr val="accent1"/>
+          </a:effectRef>
+          <a:fontRef idx="minor">
+            <a:schemeClr val="lt1"/>
+          </a:fontRef>
+        </p:style>
+        <p:txBody>
+          <a:bodyPr rtlCol="0" anchor="ctr"/>
+          <a:lstStyle/>
+          <a:p>
+            <a:pPr algn="ctr"/>
+          </a:p>
+        </p:txBody>
+      </p:sp>
+      <p:pic>
+        <p:nvPicPr>
+          <p:cNvPr id="5" name="Picture 4" descr="logo-icon.png"/>
+          <p:cNvPicPr>
+            <a:picLocks noChangeAspect="1"/>
+          </p:cNvPicPr>
+          <p:nvPr/>
+        </p:nvPicPr>
+        <p:blipFill>
+          <a:blip r:embed="rId2"/>
+          <a:stretch>
+            <a:fillRect/>
+          </a:stretch>
+        </p:blipFill>
+        <p:spPr>
+          <a:xfrm>
+            <a:off x="777240" y="822960"/>
+            <a:ext cx="1276945" cy="914400"/>
+          </a:xfrm>
+          <a:prstGeom prst="rect">
+            <a:avLst/>
+          </a:prstGeom>
+        </p:spPr>
+      </p:pic>
+      <p:sp>
+        <p:nvSpPr>
+          <p:cNvPr id="6" name="TextBox 5"/>
           <p:cNvSpPr txBox="1"/>
           <p:nvPr/>
         </p:nvSpPr>
         <p:spPr>
           <a:xfrm>
-            <a:off x="731520" y="2103120"/>
-            <a:ext cx="5486400" cy="457200"/>
+            <a:off x="731520" y="2148840"/>
+            <a:ext cx="7315200" cy="457200"/>
           </a:xfrm>
           <a:prstGeom prst="rect">
             <a:avLst/>
@@ -3162,7 +3274,7 @@
           <a:p>
             <a:pPr algn="l"/>
             <a:r>
-              <a:rPr sz="1400" b="1">
+              <a:rPr sz="1400" b="1" i="0">
                 <a:solidFill>
                   <a:srgbClr val="F5A623"/>
                 </a:solidFill>
@@ -3175,14 +3287,14 @@
       </p:sp>
       <p:sp>
         <p:nvSpPr>
-          <p:cNvPr id="4" name="TextBox 3"/>
+          <p:cNvPr id="7" name="TextBox 6"/>
           <p:cNvSpPr txBox="1"/>
           <p:nvPr/>
         </p:nvSpPr>
         <p:spPr>
           <a:xfrm>
-            <a:off x="685800" y="2468880"/>
-            <a:ext cx="8229600" cy="2011680"/>
+            <a:off x="685800" y="2542032"/>
+            <a:ext cx="9144000" cy="2011680"/>
           </a:xfrm>
           <a:prstGeom prst="rect">
             <a:avLst/>
@@ -3220,14 +3332,14 @@
       </p:sp>
       <p:sp>
         <p:nvSpPr>
-          <p:cNvPr id="5" name="TextBox 4"/>
+          <p:cNvPr id="8" name="TextBox 7"/>
           <p:cNvSpPr txBox="1"/>
           <p:nvPr/>
         </p:nvSpPr>
         <p:spPr>
           <a:xfrm>
-            <a:off x="731520" y="4480560"/>
-            <a:ext cx="7315200" cy="914400"/>
+            <a:off x="731520" y="4572000"/>
+            <a:ext cx="8229600" cy="914400"/>
           </a:xfrm>
           <a:prstGeom prst="rect">
             <a:avLst/>
@@ -3242,13 +3354,92 @@
           <a:p>
             <a:pPr algn="l"/>
             <a:r>
-              <a:rPr sz="2000" b="0">
+              <a:rPr sz="2000" b="0" i="0">
                 <a:solidFill>
                   <a:srgbClr val="9FB0AE"/>
                 </a:solidFill>
                 <a:latin typeface="Calibri"/>
               </a:rPr>
               <a:t>Convierte los reportes de una comunidad tras un sismo en recuperación verificable — de principio a fin.</a:t>
+            </a:r>
+          </a:p>
+        </p:txBody>
+      </p:sp>
+      <p:sp>
+        <p:nvSpPr>
+          <p:cNvPr id="9" name="Rectangle 8"/>
+          <p:cNvSpPr/>
+          <p:nvPr/>
+        </p:nvSpPr>
+        <p:spPr>
+          <a:xfrm>
+            <a:off x="731520" y="4343400"/>
+            <a:ext cx="1280160" cy="38100"/>
+          </a:xfrm>
+          <a:prstGeom prst="rect">
+            <a:avLst/>
+          </a:prstGeom>
+          <a:solidFill>
+            <a:srgbClr val="14B8A8"/>
+          </a:solidFill>
+          <a:ln>
+            <a:noFill/>
+          </a:ln>
+          <a:effectLst/>
+        </p:spPr>
+        <p:style>
+          <a:lnRef idx="1">
+            <a:schemeClr val="accent1"/>
+          </a:lnRef>
+          <a:fillRef idx="3">
+            <a:schemeClr val="accent1"/>
+          </a:fillRef>
+          <a:effectRef idx="2">
+            <a:schemeClr val="accent1"/>
+          </a:effectRef>
+          <a:fontRef idx="minor">
+            <a:schemeClr val="lt1"/>
+          </a:fontRef>
+        </p:style>
+        <p:txBody>
+          <a:bodyPr rtlCol="0" anchor="ctr"/>
+          <a:lstStyle/>
+          <a:p>
+            <a:pPr algn="ctr"/>
+          </a:p>
+        </p:txBody>
+      </p:sp>
+      <p:sp>
+        <p:nvSpPr>
+          <p:cNvPr id="10" name="TextBox 9"/>
+          <p:cNvSpPr txBox="1"/>
+          <p:nvPr/>
+        </p:nvSpPr>
+        <p:spPr>
+          <a:xfrm>
+            <a:off x="11247120" y="6446520"/>
+            <a:ext cx="731520" cy="320040"/>
+          </a:xfrm>
+          <a:prstGeom prst="rect">
+            <a:avLst/>
+          </a:prstGeom>
+          <a:noFill/>
+        </p:spPr>
+        <p:txBody>
+          <a:bodyPr wrap="square">
+            <a:spAutoFit/>
+          </a:bodyPr>
+          <a:lstStyle/>
+          <a:p>
+            <a:pPr algn="r"/>
+            <a:r>
+              <a:rPr sz="1100" b="0" i="0">
+                <a:solidFill>
+                  <a:srgbClr val="9FB0AE"/>
+                </a:solidFill>
+                <a:latin typeface="Calibri"/>
+              </a:rPr>
+              <a:t>1/7</a:t>
             </a:r>
           </a:p>
         </p:txBody>
@@ -3323,7 +3514,199 @@
         </p:nvSpPr>
         <p:spPr>
           <a:xfrm>
-            <a:off x="548640" y="457200"/>
+            <a:off x="-2743200" y="-2743200"/>
+            <a:ext cx="8229600" cy="8229600"/>
+          </a:xfrm>
+          <a:prstGeom prst="ellipse">
+            <a:avLst/>
+          </a:prstGeom>
+          <a:solidFill>
+            <a:srgbClr val="142B42"/>
+          </a:solidFill>
+          <a:ln>
+            <a:noFill/>
+          </a:ln>
+          <a:effectLst/>
+        </p:spPr>
+        <p:style>
+          <a:lnRef idx="1">
+            <a:schemeClr val="accent1"/>
+          </a:lnRef>
+          <a:fillRef idx="3">
+            <a:schemeClr val="accent1"/>
+          </a:fillRef>
+          <a:effectRef idx="2">
+            <a:schemeClr val="accent1"/>
+          </a:effectRef>
+          <a:fontRef idx="minor">
+            <a:schemeClr val="lt1"/>
+          </a:fontRef>
+        </p:style>
+        <p:txBody>
+          <a:bodyPr rtlCol="0" anchor="ctr"/>
+          <a:lstStyle/>
+          <a:p>
+            <a:pPr algn="ctr"/>
+          </a:p>
+        </p:txBody>
+      </p:sp>
+      <p:sp>
+        <p:nvSpPr>
+          <p:cNvPr id="4" name="Oval 3"/>
+          <p:cNvSpPr/>
+          <p:nvPr/>
+        </p:nvSpPr>
+        <p:spPr>
+          <a:xfrm>
+            <a:off x="9601200" y="4114800"/>
+            <a:ext cx="5486400" cy="5486400"/>
+          </a:xfrm>
+          <a:prstGeom prst="ellipse">
+            <a:avLst/>
+          </a:prstGeom>
+          <a:solidFill>
+            <a:srgbClr val="142B42"/>
+          </a:solidFill>
+          <a:ln>
+            <a:noFill/>
+          </a:ln>
+          <a:effectLst/>
+        </p:spPr>
+        <p:style>
+          <a:lnRef idx="1">
+            <a:schemeClr val="accent1"/>
+          </a:lnRef>
+          <a:fillRef idx="3">
+            <a:schemeClr val="accent1"/>
+          </a:fillRef>
+          <a:effectRef idx="2">
+            <a:schemeClr val="accent1"/>
+          </a:effectRef>
+          <a:fontRef idx="minor">
+            <a:schemeClr val="lt1"/>
+          </a:fontRef>
+        </p:style>
+        <p:txBody>
+          <a:bodyPr rtlCol="0" anchor="ctr"/>
+          <a:lstStyle/>
+          <a:p>
+            <a:pPr algn="ctr"/>
+          </a:p>
+        </p:txBody>
+      </p:sp>
+      <p:sp>
+        <p:nvSpPr>
+          <p:cNvPr id="5" name="Rounded Rectangle 4"/>
+          <p:cNvSpPr/>
+          <p:nvPr/>
+        </p:nvSpPr>
+        <p:spPr>
+          <a:xfrm>
+            <a:off x="502920" y="365760"/>
+            <a:ext cx="384048" cy="384048"/>
+          </a:xfrm>
+          <a:prstGeom prst="roundRect">
+            <a:avLst>
+              <a:gd name="adj" fmla="val 28000"/>
+            </a:avLst>
+          </a:prstGeom>
+          <a:solidFill>
+            <a:srgbClr val="FFFFFF"/>
+          </a:solidFill>
+          <a:ln>
+            <a:noFill/>
+          </a:ln>
+          <a:effectLst/>
+        </p:spPr>
+        <p:style>
+          <a:lnRef idx="1">
+            <a:schemeClr val="accent1"/>
+          </a:lnRef>
+          <a:fillRef idx="3">
+            <a:schemeClr val="accent1"/>
+          </a:fillRef>
+          <a:effectRef idx="2">
+            <a:schemeClr val="accent1"/>
+          </a:effectRef>
+          <a:fontRef idx="minor">
+            <a:schemeClr val="lt1"/>
+          </a:fontRef>
+        </p:style>
+        <p:txBody>
+          <a:bodyPr rtlCol="0" anchor="ctr"/>
+          <a:lstStyle/>
+          <a:p>
+            <a:pPr algn="ctr"/>
+          </a:p>
+        </p:txBody>
+      </p:sp>
+      <p:pic>
+        <p:nvPicPr>
+          <p:cNvPr id="6" name="Picture 5" descr="logo-icon.png"/>
+          <p:cNvPicPr>
+            <a:picLocks noChangeAspect="1"/>
+          </p:cNvPicPr>
+          <p:nvPr/>
+        </p:nvPicPr>
+        <p:blipFill>
+          <a:blip r:embed="rId2"/>
+          <a:stretch>
+            <a:fillRect/>
+          </a:stretch>
+        </p:blipFill>
+        <p:spPr>
+          <a:xfrm>
+            <a:off x="557784" y="420624"/>
+            <a:ext cx="383084" cy="274320"/>
+          </a:xfrm>
+          <a:prstGeom prst="rect">
+            <a:avLst/>
+          </a:prstGeom>
+        </p:spPr>
+      </p:pic>
+      <p:sp>
+        <p:nvSpPr>
+          <p:cNvPr id="7" name="TextBox 6"/>
+          <p:cNvSpPr txBox="1"/>
+          <p:nvPr/>
+        </p:nvSpPr>
+        <p:spPr>
+          <a:xfrm>
+            <a:off x="987552" y="384048"/>
+            <a:ext cx="3657600" cy="365760"/>
+          </a:xfrm>
+          <a:prstGeom prst="rect">
+            <a:avLst/>
+          </a:prstGeom>
+          <a:noFill/>
+        </p:spPr>
+        <p:txBody>
+          <a:bodyPr wrap="none">
+            <a:spAutoFit/>
+          </a:bodyPr>
+          <a:lstStyle/>
+          <a:p>
+            <a:r>
+              <a:rPr sz="1100" b="1">
+                <a:solidFill>
+                  <a:srgbClr val="9FB0AE"/>
+                </a:solidFill>
+                <a:latin typeface="Calibri"/>
+              </a:rPr>
+              <a:t>REACTIVA TERRITORIO</a:t>
+            </a:r>
+          </a:p>
+        </p:txBody>
+      </p:sp>
+      <p:sp>
+        <p:nvSpPr>
+          <p:cNvPr id="8" name="Oval 7"/>
+          <p:cNvSpPr/>
+          <p:nvPr/>
+        </p:nvSpPr>
+        <p:spPr>
+          <a:xfrm>
+            <a:off x="548640" y="1143000"/>
             <a:ext cx="365760" cy="365760"/>
           </a:xfrm>
           <a:prstGeom prst="ellipse">
@@ -3335,6 +3718,7 @@
           <a:ln>
             <a:noFill/>
           </a:ln>
+          <a:effectLst/>
         </p:spPr>
         <p:style>
           <a:lnRef idx="1">
@@ -3368,13 +3752,13 @@
       </p:sp>
       <p:sp>
         <p:nvSpPr>
-          <p:cNvPr id="4" name="TextBox 3"/>
+          <p:cNvPr id="9" name="TextBox 8"/>
           <p:cNvSpPr txBox="1"/>
           <p:nvPr/>
         </p:nvSpPr>
         <p:spPr>
           <a:xfrm>
-            <a:off x="1051560" y="475488"/>
+            <a:off x="1051560" y="1161288"/>
             <a:ext cx="5486400" cy="365760"/>
           </a:xfrm>
           <a:prstGeom prst="rect">
@@ -3390,7 +3774,7 @@
           <a:p>
             <a:pPr algn="l"/>
             <a:r>
-              <a:rPr sz="1300" b="1">
+              <a:rPr sz="1300" b="1" i="0">
                 <a:solidFill>
                   <a:srgbClr val="14B8A8"/>
                 </a:solidFill>
@@ -3403,14 +3787,14 @@
       </p:sp>
       <p:sp>
         <p:nvSpPr>
-          <p:cNvPr id="5" name="TextBox 4"/>
+          <p:cNvPr id="10" name="TextBox 9"/>
           <p:cNvSpPr txBox="1"/>
           <p:nvPr/>
         </p:nvSpPr>
         <p:spPr>
           <a:xfrm>
-            <a:off x="548640" y="1005840"/>
-            <a:ext cx="10515600" cy="1463040"/>
+            <a:off x="548640" y="1691640"/>
+            <a:ext cx="10698480" cy="1463040"/>
           </a:xfrm>
           <a:prstGeom prst="rect">
             <a:avLst/>
@@ -3425,7 +3809,7 @@
           <a:p>
             <a:pPr algn="l"/>
             <a:r>
-              <a:rPr sz="3400" b="1">
+              <a:rPr sz="3300" b="1" i="0">
                 <a:solidFill>
                   <a:srgbClr val="FFFFFF"/>
                 </a:solidFill>
@@ -3438,14 +3822,14 @@
       </p:sp>
       <p:sp>
         <p:nvSpPr>
-          <p:cNvPr id="6" name="TextBox 5"/>
+          <p:cNvPr id="11" name="TextBox 10"/>
           <p:cNvSpPr txBox="1"/>
           <p:nvPr/>
         </p:nvSpPr>
         <p:spPr>
           <a:xfrm>
-            <a:off x="548640" y="1828800"/>
-            <a:ext cx="9601200" cy="731520"/>
+            <a:off x="548640" y="2514600"/>
+            <a:ext cx="9875520" cy="731520"/>
           </a:xfrm>
           <a:prstGeom prst="rect">
             <a:avLst/>
@@ -3460,7 +3844,7 @@
           <a:p>
             <a:pPr algn="l"/>
             <a:r>
-              <a:rPr sz="1700" b="0">
+              <a:rPr sz="1600" b="0" i="0">
                 <a:solidFill>
                   <a:srgbClr val="9FB0AE"/>
                 </a:solidFill>
@@ -3473,14 +3857,14 @@
       </p:sp>
       <p:sp>
         <p:nvSpPr>
-          <p:cNvPr id="7" name="TextBox 6"/>
+          <p:cNvPr id="12" name="TextBox 11"/>
           <p:cNvSpPr txBox="1"/>
           <p:nvPr/>
         </p:nvSpPr>
         <p:spPr>
           <a:xfrm>
-            <a:off x="548640" y="2834640"/>
-            <a:ext cx="10058400" cy="4114800"/>
+            <a:off x="548640" y="3429000"/>
+            <a:ext cx="10332720" cy="4114800"/>
           </a:xfrm>
           <a:prstGeom prst="rect">
             <a:avLst/>
@@ -3495,17 +3879,26 @@
           <a:p>
             <a:pPr>
               <a:spcAft>
-                <a:spcPts val="1400"/>
+                <a:spcPts val="1600"/>
               </a:spcAft>
             </a:pPr>
             <a:r>
               <a:rPr sz="1600" b="1">
                 <a:solidFill>
+                  <a:srgbClr val="14B8A8"/>
+                </a:solidFill>
+                <a:latin typeface="Calibri"/>
+              </a:rPr>
+              <a:t>→  </a:t>
+            </a:r>
+            <a:r>
+              <a:rPr sz="1600" b="1">
+                <a:solidFill>
                   <a:srgbClr val="FFFFFF"/>
                 </a:solidFill>
                 <a:latin typeface="Calibri"/>
               </a:rPr>
-              <a:t>→  Reportes perdidos</a:t>
+              <a:t>Reportes perdidos</a:t>
             </a:r>
             <a:r>
               <a:rPr sz="1400">
@@ -3520,17 +3913,26 @@
           <a:p>
             <a:pPr>
               <a:spcAft>
-                <a:spcPts val="1400"/>
+                <a:spcPts val="1600"/>
               </a:spcAft>
             </a:pPr>
             <a:r>
               <a:rPr sz="1600" b="1">
                 <a:solidFill>
+                  <a:srgbClr val="14B8A8"/>
+                </a:solidFill>
+                <a:latin typeface="Calibri"/>
+              </a:rPr>
+              <a:t>→  </a:t>
+            </a:r>
+            <a:r>
+              <a:rPr sz="1600" b="1">
+                <a:solidFill>
                   <a:srgbClr val="FFFFFF"/>
                 </a:solidFill>
                 <a:latin typeface="Calibri"/>
               </a:rPr>
-              <a:t>→  Ayuda mal dirigida</a:t>
+              <a:t>Ayuda mal dirigida</a:t>
             </a:r>
             <a:r>
               <a:rPr sz="1400">
@@ -3545,17 +3947,26 @@
           <a:p>
             <a:pPr>
               <a:spcAft>
-                <a:spcPts val="1400"/>
+                <a:spcPts val="1600"/>
               </a:spcAft>
             </a:pPr>
             <a:r>
               <a:rPr sz="1600" b="1">
                 <a:solidFill>
+                  <a:srgbClr val="14B8A8"/>
+                </a:solidFill>
+                <a:latin typeface="Calibri"/>
+              </a:rPr>
+              <a:t>→  </a:t>
+            </a:r>
+            <a:r>
+              <a:rPr sz="1600" b="1">
+                <a:solidFill>
                   <a:srgbClr val="FFFFFF"/>
                 </a:solidFill>
                 <a:latin typeface="Calibri"/>
               </a:rPr>
-              <a:t>→  Nadie mide el resultado</a:t>
+              <a:t>Nadie mide el resultado</a:t>
             </a:r>
             <a:r>
               <a:rPr sz="1400">
@@ -3565,6 +3976,41 @@
                 <a:latin typeface="Calibri"/>
               </a:rPr>
               <a:t>  — no hay forma de confirmar si un caso quedó atendido.</a:t>
+            </a:r>
+          </a:p>
+        </p:txBody>
+      </p:sp>
+      <p:sp>
+        <p:nvSpPr>
+          <p:cNvPr id="13" name="TextBox 12"/>
+          <p:cNvSpPr txBox="1"/>
+          <p:nvPr/>
+        </p:nvSpPr>
+        <p:spPr>
+          <a:xfrm>
+            <a:off x="11247120" y="6446520"/>
+            <a:ext cx="731520" cy="320040"/>
+          </a:xfrm>
+          <a:prstGeom prst="rect">
+            <a:avLst/>
+          </a:prstGeom>
+          <a:noFill/>
+        </p:spPr>
+        <p:txBody>
+          <a:bodyPr wrap="square">
+            <a:spAutoFit/>
+          </a:bodyPr>
+          <a:lstStyle/>
+          <a:p>
+            <a:pPr algn="r"/>
+            <a:r>
+              <a:rPr sz="1100" b="0" i="0">
+                <a:solidFill>
+                  <a:srgbClr val="9FB0AE"/>
+                </a:solidFill>
+                <a:latin typeface="Calibri"/>
+              </a:rPr>
+              <a:t>2/7</a:t>
             </a:r>
           </a:p>
         </p:txBody>
@@ -3639,7 +4085,199 @@
         </p:nvSpPr>
         <p:spPr>
           <a:xfrm>
-            <a:off x="548640" y="457200"/>
+            <a:off x="-2743200" y="-2743200"/>
+            <a:ext cx="8229600" cy="8229600"/>
+          </a:xfrm>
+          <a:prstGeom prst="ellipse">
+            <a:avLst/>
+          </a:prstGeom>
+          <a:solidFill>
+            <a:srgbClr val="142B42"/>
+          </a:solidFill>
+          <a:ln>
+            <a:noFill/>
+          </a:ln>
+          <a:effectLst/>
+        </p:spPr>
+        <p:style>
+          <a:lnRef idx="1">
+            <a:schemeClr val="accent1"/>
+          </a:lnRef>
+          <a:fillRef idx="3">
+            <a:schemeClr val="accent1"/>
+          </a:fillRef>
+          <a:effectRef idx="2">
+            <a:schemeClr val="accent1"/>
+          </a:effectRef>
+          <a:fontRef idx="minor">
+            <a:schemeClr val="lt1"/>
+          </a:fontRef>
+        </p:style>
+        <p:txBody>
+          <a:bodyPr rtlCol="0" anchor="ctr"/>
+          <a:lstStyle/>
+          <a:p>
+            <a:pPr algn="ctr"/>
+          </a:p>
+        </p:txBody>
+      </p:sp>
+      <p:sp>
+        <p:nvSpPr>
+          <p:cNvPr id="4" name="Oval 3"/>
+          <p:cNvSpPr/>
+          <p:nvPr/>
+        </p:nvSpPr>
+        <p:spPr>
+          <a:xfrm>
+            <a:off x="9601200" y="4114800"/>
+            <a:ext cx="5486400" cy="5486400"/>
+          </a:xfrm>
+          <a:prstGeom prst="ellipse">
+            <a:avLst/>
+          </a:prstGeom>
+          <a:solidFill>
+            <a:srgbClr val="142B42"/>
+          </a:solidFill>
+          <a:ln>
+            <a:noFill/>
+          </a:ln>
+          <a:effectLst/>
+        </p:spPr>
+        <p:style>
+          <a:lnRef idx="1">
+            <a:schemeClr val="accent1"/>
+          </a:lnRef>
+          <a:fillRef idx="3">
+            <a:schemeClr val="accent1"/>
+          </a:fillRef>
+          <a:effectRef idx="2">
+            <a:schemeClr val="accent1"/>
+          </a:effectRef>
+          <a:fontRef idx="minor">
+            <a:schemeClr val="lt1"/>
+          </a:fontRef>
+        </p:style>
+        <p:txBody>
+          <a:bodyPr rtlCol="0" anchor="ctr"/>
+          <a:lstStyle/>
+          <a:p>
+            <a:pPr algn="ctr"/>
+          </a:p>
+        </p:txBody>
+      </p:sp>
+      <p:sp>
+        <p:nvSpPr>
+          <p:cNvPr id="5" name="Rounded Rectangle 4"/>
+          <p:cNvSpPr/>
+          <p:nvPr/>
+        </p:nvSpPr>
+        <p:spPr>
+          <a:xfrm>
+            <a:off x="502920" y="365760"/>
+            <a:ext cx="384048" cy="384048"/>
+          </a:xfrm>
+          <a:prstGeom prst="roundRect">
+            <a:avLst>
+              <a:gd name="adj" fmla="val 28000"/>
+            </a:avLst>
+          </a:prstGeom>
+          <a:solidFill>
+            <a:srgbClr val="FFFFFF"/>
+          </a:solidFill>
+          <a:ln>
+            <a:noFill/>
+          </a:ln>
+          <a:effectLst/>
+        </p:spPr>
+        <p:style>
+          <a:lnRef idx="1">
+            <a:schemeClr val="accent1"/>
+          </a:lnRef>
+          <a:fillRef idx="3">
+            <a:schemeClr val="accent1"/>
+          </a:fillRef>
+          <a:effectRef idx="2">
+            <a:schemeClr val="accent1"/>
+          </a:effectRef>
+          <a:fontRef idx="minor">
+            <a:schemeClr val="lt1"/>
+          </a:fontRef>
+        </p:style>
+        <p:txBody>
+          <a:bodyPr rtlCol="0" anchor="ctr"/>
+          <a:lstStyle/>
+          <a:p>
+            <a:pPr algn="ctr"/>
+          </a:p>
+        </p:txBody>
+      </p:sp>
+      <p:pic>
+        <p:nvPicPr>
+          <p:cNvPr id="6" name="Picture 5" descr="logo-icon.png"/>
+          <p:cNvPicPr>
+            <a:picLocks noChangeAspect="1"/>
+          </p:cNvPicPr>
+          <p:nvPr/>
+        </p:nvPicPr>
+        <p:blipFill>
+          <a:blip r:embed="rId2"/>
+          <a:stretch>
+            <a:fillRect/>
+          </a:stretch>
+        </p:blipFill>
+        <p:spPr>
+          <a:xfrm>
+            <a:off x="557784" y="420624"/>
+            <a:ext cx="383084" cy="274320"/>
+          </a:xfrm>
+          <a:prstGeom prst="rect">
+            <a:avLst/>
+          </a:prstGeom>
+        </p:spPr>
+      </p:pic>
+      <p:sp>
+        <p:nvSpPr>
+          <p:cNvPr id="7" name="TextBox 6"/>
+          <p:cNvSpPr txBox="1"/>
+          <p:nvPr/>
+        </p:nvSpPr>
+        <p:spPr>
+          <a:xfrm>
+            <a:off x="987552" y="384048"/>
+            <a:ext cx="3657600" cy="365760"/>
+          </a:xfrm>
+          <a:prstGeom prst="rect">
+            <a:avLst/>
+          </a:prstGeom>
+          <a:noFill/>
+        </p:spPr>
+        <p:txBody>
+          <a:bodyPr wrap="none">
+            <a:spAutoFit/>
+          </a:bodyPr>
+          <a:lstStyle/>
+          <a:p>
+            <a:r>
+              <a:rPr sz="1100" b="1">
+                <a:solidFill>
+                  <a:srgbClr val="9FB0AE"/>
+                </a:solidFill>
+                <a:latin typeface="Calibri"/>
+              </a:rPr>
+              <a:t>REACTIVA TERRITORIO</a:t>
+            </a:r>
+          </a:p>
+        </p:txBody>
+      </p:sp>
+      <p:sp>
+        <p:nvSpPr>
+          <p:cNvPr id="8" name="Oval 7"/>
+          <p:cNvSpPr/>
+          <p:nvPr/>
+        </p:nvSpPr>
+        <p:spPr>
+          <a:xfrm>
+            <a:off x="548640" y="1143000"/>
             <a:ext cx="365760" cy="365760"/>
           </a:xfrm>
           <a:prstGeom prst="ellipse">
@@ -3651,6 +4289,7 @@
           <a:ln>
             <a:noFill/>
           </a:ln>
+          <a:effectLst/>
         </p:spPr>
         <p:style>
           <a:lnRef idx="1">
@@ -3684,13 +4323,13 @@
       </p:sp>
       <p:sp>
         <p:nvSpPr>
-          <p:cNvPr id="4" name="TextBox 3"/>
+          <p:cNvPr id="9" name="TextBox 8"/>
           <p:cNvSpPr txBox="1"/>
           <p:nvPr/>
         </p:nvSpPr>
         <p:spPr>
           <a:xfrm>
-            <a:off x="1051560" y="475488"/>
+            <a:off x="1051560" y="1161288"/>
             <a:ext cx="5486400" cy="365760"/>
           </a:xfrm>
           <a:prstGeom prst="rect">
@@ -3706,7 +4345,7 @@
           <a:p>
             <a:pPr algn="l"/>
             <a:r>
-              <a:rPr sz="1300" b="1">
+              <a:rPr sz="1300" b="1" i="0">
                 <a:solidFill>
                   <a:srgbClr val="14B8A8"/>
                 </a:solidFill>
@@ -3719,13 +4358,13 @@
       </p:sp>
       <p:sp>
         <p:nvSpPr>
-          <p:cNvPr id="5" name="TextBox 4"/>
+          <p:cNvPr id="10" name="TextBox 9"/>
           <p:cNvSpPr txBox="1"/>
           <p:nvPr/>
         </p:nvSpPr>
         <p:spPr>
           <a:xfrm>
-            <a:off x="548640" y="1005840"/>
+            <a:off x="548640" y="1691640"/>
             <a:ext cx="10515600" cy="1097280"/>
           </a:xfrm>
           <a:prstGeom prst="rect">
@@ -3741,7 +4380,7 @@
           <a:p>
             <a:pPr algn="l"/>
             <a:r>
-              <a:rPr sz="3200" b="1">
+              <a:rPr sz="3100" b="1" i="0">
                 <a:solidFill>
                   <a:srgbClr val="FFFFFF"/>
                 </a:solidFill>
@@ -3754,13 +4393,13 @@
       </p:sp>
       <p:sp>
         <p:nvSpPr>
-          <p:cNvPr id="6" name="TextBox 5"/>
+          <p:cNvPr id="11" name="TextBox 10"/>
           <p:cNvSpPr txBox="1"/>
           <p:nvPr/>
         </p:nvSpPr>
         <p:spPr>
           <a:xfrm>
-            <a:off x="548640" y="2286000"/>
+            <a:off x="548640" y="2788920"/>
             <a:ext cx="10515600" cy="4114800"/>
           </a:xfrm>
           <a:prstGeom prst="rect">
@@ -3776,20 +4415,29 @@
           <a:p>
             <a:pPr>
               <a:spcAft>
-                <a:spcPts val="1400"/>
+                <a:spcPts val="1600"/>
               </a:spcAft>
             </a:pPr>
             <a:r>
-              <a:rPr sz="1600" b="1">
+              <a:rPr sz="1700" b="1">
+                <a:solidFill>
+                  <a:srgbClr val="14B8A8"/>
+                </a:solidFill>
+                <a:latin typeface="Calibri"/>
+              </a:rPr>
+              <a:t>→  </a:t>
+            </a:r>
+            <a:r>
+              <a:rPr sz="1700" b="1">
                 <a:solidFill>
                   <a:srgbClr val="FFFFFF"/>
                 </a:solidFill>
                 <a:latin typeface="Calibri"/>
               </a:rPr>
-              <a:t>→  Reportar</a:t>
-            </a:r>
-            <a:r>
-              <a:rPr sz="1400">
+              <a:t>Reportar</a:t>
+            </a:r>
+            <a:r>
+              <a:rPr sz="1500">
                 <a:solidFill>
                   <a:srgbClr val="9FB0AE"/>
                 </a:solidFill>
@@ -3801,20 +4449,29 @@
           <a:p>
             <a:pPr>
               <a:spcAft>
-                <a:spcPts val="1400"/>
+                <a:spcPts val="1600"/>
               </a:spcAft>
             </a:pPr>
             <a:r>
-              <a:rPr sz="1600" b="1">
+              <a:rPr sz="1700" b="1">
+                <a:solidFill>
+                  <a:srgbClr val="14B8A8"/>
+                </a:solidFill>
+                <a:latin typeface="Calibri"/>
+              </a:rPr>
+              <a:t>→  </a:t>
+            </a:r>
+            <a:r>
+              <a:rPr sz="1700" b="1">
                 <a:solidFill>
                   <a:srgbClr val="FFFFFF"/>
                 </a:solidFill>
                 <a:latin typeface="Calibri"/>
               </a:rPr>
-              <a:t>→  Verificar</a:t>
-            </a:r>
-            <a:r>
-              <a:rPr sz="1400">
+              <a:t>Verificar</a:t>
+            </a:r>
+            <a:r>
+              <a:rPr sz="1500">
                 <a:solidFill>
                   <a:srgbClr val="9FB0AE"/>
                 </a:solidFill>
@@ -3826,20 +4483,29 @@
           <a:p>
             <a:pPr>
               <a:spcAft>
-                <a:spcPts val="1400"/>
+                <a:spcPts val="1600"/>
               </a:spcAft>
             </a:pPr>
             <a:r>
-              <a:rPr sz="1600" b="1">
+              <a:rPr sz="1700" b="1">
+                <a:solidFill>
+                  <a:srgbClr val="14B8A8"/>
+                </a:solidFill>
+                <a:latin typeface="Calibri"/>
+              </a:rPr>
+              <a:t>→  </a:t>
+            </a:r>
+            <a:r>
+              <a:rPr sz="1700" b="1">
                 <a:solidFill>
                   <a:srgbClr val="FFFFFF"/>
                 </a:solidFill>
                 <a:latin typeface="Calibri"/>
               </a:rPr>
-              <a:t>→  Conectar</a:t>
-            </a:r>
-            <a:r>
-              <a:rPr sz="1400">
+              <a:t>Conectar</a:t>
+            </a:r>
+            <a:r>
+              <a:rPr sz="1500">
                 <a:solidFill>
                   <a:srgbClr val="9FB0AE"/>
                 </a:solidFill>
@@ -3851,26 +4517,70 @@
           <a:p>
             <a:pPr>
               <a:spcAft>
-                <a:spcPts val="1400"/>
+                <a:spcPts val="1600"/>
               </a:spcAft>
             </a:pPr>
             <a:r>
-              <a:rPr sz="1600" b="1">
+              <a:rPr sz="1700" b="1">
+                <a:solidFill>
+                  <a:srgbClr val="14B8A8"/>
+                </a:solidFill>
+                <a:latin typeface="Calibri"/>
+              </a:rPr>
+              <a:t>→  </a:t>
+            </a:r>
+            <a:r>
+              <a:rPr sz="1700" b="1">
                 <a:solidFill>
                   <a:srgbClr val="FFFFFF"/>
                 </a:solidFill>
                 <a:latin typeface="Calibri"/>
               </a:rPr>
-              <a:t>→  Confirmar</a:t>
-            </a:r>
-            <a:r>
-              <a:rPr sz="1400">
+              <a:t>Confirmar</a:t>
+            </a:r>
+            <a:r>
+              <a:rPr sz="1500">
                 <a:solidFill>
                   <a:srgbClr val="9FB0AE"/>
                 </a:solidFill>
                 <a:latin typeface="Calibri"/>
               </a:rPr>
               <a:t>  — seguimiento con evidencia hasta que la comunidad cierra el caso.</a:t>
+            </a:r>
+          </a:p>
+        </p:txBody>
+      </p:sp>
+      <p:sp>
+        <p:nvSpPr>
+          <p:cNvPr id="12" name="TextBox 11"/>
+          <p:cNvSpPr txBox="1"/>
+          <p:nvPr/>
+        </p:nvSpPr>
+        <p:spPr>
+          <a:xfrm>
+            <a:off x="11247120" y="6446520"/>
+            <a:ext cx="731520" cy="320040"/>
+          </a:xfrm>
+          <a:prstGeom prst="rect">
+            <a:avLst/>
+          </a:prstGeom>
+          <a:noFill/>
+        </p:spPr>
+        <p:txBody>
+          <a:bodyPr wrap="square">
+            <a:spAutoFit/>
+          </a:bodyPr>
+          <a:lstStyle/>
+          <a:p>
+            <a:pPr algn="r"/>
+            <a:r>
+              <a:rPr sz="1100" b="0" i="0">
+                <a:solidFill>
+                  <a:srgbClr val="9FB0AE"/>
+                </a:solidFill>
+                <a:latin typeface="Calibri"/>
+              </a:rPr>
+              <a:t>3/7</a:t>
             </a:r>
           </a:p>
         </p:txBody>
@@ -3945,7 +4655,199 @@
         </p:nvSpPr>
         <p:spPr>
           <a:xfrm>
-            <a:off x="548640" y="457200"/>
+            <a:off x="-2743200" y="-2743200"/>
+            <a:ext cx="8229600" cy="8229600"/>
+          </a:xfrm>
+          <a:prstGeom prst="ellipse">
+            <a:avLst/>
+          </a:prstGeom>
+          <a:solidFill>
+            <a:srgbClr val="142B42"/>
+          </a:solidFill>
+          <a:ln>
+            <a:noFill/>
+          </a:ln>
+          <a:effectLst/>
+        </p:spPr>
+        <p:style>
+          <a:lnRef idx="1">
+            <a:schemeClr val="accent1"/>
+          </a:lnRef>
+          <a:fillRef idx="3">
+            <a:schemeClr val="accent1"/>
+          </a:fillRef>
+          <a:effectRef idx="2">
+            <a:schemeClr val="accent1"/>
+          </a:effectRef>
+          <a:fontRef idx="minor">
+            <a:schemeClr val="lt1"/>
+          </a:fontRef>
+        </p:style>
+        <p:txBody>
+          <a:bodyPr rtlCol="0" anchor="ctr"/>
+          <a:lstStyle/>
+          <a:p>
+            <a:pPr algn="ctr"/>
+          </a:p>
+        </p:txBody>
+      </p:sp>
+      <p:sp>
+        <p:nvSpPr>
+          <p:cNvPr id="4" name="Oval 3"/>
+          <p:cNvSpPr/>
+          <p:nvPr/>
+        </p:nvSpPr>
+        <p:spPr>
+          <a:xfrm>
+            <a:off x="9601200" y="4114800"/>
+            <a:ext cx="5486400" cy="5486400"/>
+          </a:xfrm>
+          <a:prstGeom prst="ellipse">
+            <a:avLst/>
+          </a:prstGeom>
+          <a:solidFill>
+            <a:srgbClr val="142B42"/>
+          </a:solidFill>
+          <a:ln>
+            <a:noFill/>
+          </a:ln>
+          <a:effectLst/>
+        </p:spPr>
+        <p:style>
+          <a:lnRef idx="1">
+            <a:schemeClr val="accent1"/>
+          </a:lnRef>
+          <a:fillRef idx="3">
+            <a:schemeClr val="accent1"/>
+          </a:fillRef>
+          <a:effectRef idx="2">
+            <a:schemeClr val="accent1"/>
+          </a:effectRef>
+          <a:fontRef idx="minor">
+            <a:schemeClr val="lt1"/>
+          </a:fontRef>
+        </p:style>
+        <p:txBody>
+          <a:bodyPr rtlCol="0" anchor="ctr"/>
+          <a:lstStyle/>
+          <a:p>
+            <a:pPr algn="ctr"/>
+          </a:p>
+        </p:txBody>
+      </p:sp>
+      <p:sp>
+        <p:nvSpPr>
+          <p:cNvPr id="5" name="Rounded Rectangle 4"/>
+          <p:cNvSpPr/>
+          <p:nvPr/>
+        </p:nvSpPr>
+        <p:spPr>
+          <a:xfrm>
+            <a:off x="502920" y="365760"/>
+            <a:ext cx="384048" cy="384048"/>
+          </a:xfrm>
+          <a:prstGeom prst="roundRect">
+            <a:avLst>
+              <a:gd name="adj" fmla="val 28000"/>
+            </a:avLst>
+          </a:prstGeom>
+          <a:solidFill>
+            <a:srgbClr val="FFFFFF"/>
+          </a:solidFill>
+          <a:ln>
+            <a:noFill/>
+          </a:ln>
+          <a:effectLst/>
+        </p:spPr>
+        <p:style>
+          <a:lnRef idx="1">
+            <a:schemeClr val="accent1"/>
+          </a:lnRef>
+          <a:fillRef idx="3">
+            <a:schemeClr val="accent1"/>
+          </a:fillRef>
+          <a:effectRef idx="2">
+            <a:schemeClr val="accent1"/>
+          </a:effectRef>
+          <a:fontRef idx="minor">
+            <a:schemeClr val="lt1"/>
+          </a:fontRef>
+        </p:style>
+        <p:txBody>
+          <a:bodyPr rtlCol="0" anchor="ctr"/>
+          <a:lstStyle/>
+          <a:p>
+            <a:pPr algn="ctr"/>
+          </a:p>
+        </p:txBody>
+      </p:sp>
+      <p:pic>
+        <p:nvPicPr>
+          <p:cNvPr id="6" name="Picture 5" descr="logo-icon.png"/>
+          <p:cNvPicPr>
+            <a:picLocks noChangeAspect="1"/>
+          </p:cNvPicPr>
+          <p:nvPr/>
+        </p:nvPicPr>
+        <p:blipFill>
+          <a:blip r:embed="rId2"/>
+          <a:stretch>
+            <a:fillRect/>
+          </a:stretch>
+        </p:blipFill>
+        <p:spPr>
+          <a:xfrm>
+            <a:off x="557784" y="420624"/>
+            <a:ext cx="383084" cy="274320"/>
+          </a:xfrm>
+          <a:prstGeom prst="rect">
+            <a:avLst/>
+          </a:prstGeom>
+        </p:spPr>
+      </p:pic>
+      <p:sp>
+        <p:nvSpPr>
+          <p:cNvPr id="7" name="TextBox 6"/>
+          <p:cNvSpPr txBox="1"/>
+          <p:nvPr/>
+        </p:nvSpPr>
+        <p:spPr>
+          <a:xfrm>
+            <a:off x="987552" y="384048"/>
+            <a:ext cx="3657600" cy="365760"/>
+          </a:xfrm>
+          <a:prstGeom prst="rect">
+            <a:avLst/>
+          </a:prstGeom>
+          <a:noFill/>
+        </p:spPr>
+        <p:txBody>
+          <a:bodyPr wrap="none">
+            <a:spAutoFit/>
+          </a:bodyPr>
+          <a:lstStyle/>
+          <a:p>
+            <a:r>
+              <a:rPr sz="1100" b="1">
+                <a:solidFill>
+                  <a:srgbClr val="9FB0AE"/>
+                </a:solidFill>
+                <a:latin typeface="Calibri"/>
+              </a:rPr>
+              <a:t>REACTIVA TERRITORIO</a:t>
+            </a:r>
+          </a:p>
+        </p:txBody>
+      </p:sp>
+      <p:sp>
+        <p:nvSpPr>
+          <p:cNvPr id="8" name="Oval 7"/>
+          <p:cNvSpPr/>
+          <p:nvPr/>
+        </p:nvSpPr>
+        <p:spPr>
+          <a:xfrm>
+            <a:off x="548640" y="1143000"/>
             <a:ext cx="365760" cy="365760"/>
           </a:xfrm>
           <a:prstGeom prst="ellipse">
@@ -3957,6 +4859,7 @@
           <a:ln>
             <a:noFill/>
           </a:ln>
+          <a:effectLst/>
         </p:spPr>
         <p:style>
           <a:lnRef idx="1">
@@ -3990,13 +4893,13 @@
       </p:sp>
       <p:sp>
         <p:nvSpPr>
-          <p:cNvPr id="4" name="TextBox 3"/>
+          <p:cNvPr id="9" name="TextBox 8"/>
           <p:cNvSpPr txBox="1"/>
           <p:nvPr/>
         </p:nvSpPr>
         <p:spPr>
           <a:xfrm>
-            <a:off x="1051560" y="475488"/>
+            <a:off x="1051560" y="1161288"/>
             <a:ext cx="5486400" cy="365760"/>
           </a:xfrm>
           <a:prstGeom prst="rect">
@@ -4012,7 +4915,7 @@
           <a:p>
             <a:pPr algn="l"/>
             <a:r>
-              <a:rPr sz="1300" b="1">
+              <a:rPr sz="1300" b="1" i="0">
                 <a:solidFill>
                   <a:srgbClr val="14B8A8"/>
                 </a:solidFill>
@@ -4025,13 +4928,13 @@
       </p:sp>
       <p:sp>
         <p:nvSpPr>
-          <p:cNvPr id="5" name="TextBox 4"/>
+          <p:cNvPr id="10" name="TextBox 9"/>
           <p:cNvSpPr txBox="1"/>
           <p:nvPr/>
         </p:nvSpPr>
         <p:spPr>
           <a:xfrm>
-            <a:off x="548640" y="1005840"/>
+            <a:off x="548640" y="1691640"/>
             <a:ext cx="10515600" cy="1097280"/>
           </a:xfrm>
           <a:prstGeom prst="rect">
@@ -4047,7 +4950,7 @@
           <a:p>
             <a:pPr algn="l"/>
             <a:r>
-              <a:rPr sz="3000" b="1">
+              <a:rPr sz="2900" b="1" i="0">
                 <a:solidFill>
                   <a:srgbClr val="FFFFFF"/>
                 </a:solidFill>
@@ -4060,14 +4963,14 @@
       </p:sp>
       <p:sp>
         <p:nvSpPr>
-          <p:cNvPr id="6" name="Oval 5"/>
+          <p:cNvPr id="11" name="Oval 10"/>
           <p:cNvSpPr/>
           <p:nvPr/>
         </p:nvSpPr>
         <p:spPr>
           <a:xfrm>
-            <a:off x="548640" y="2359152"/>
-            <a:ext cx="128016" cy="128016"/>
+            <a:off x="548640" y="2962656"/>
+            <a:ext cx="118872" cy="118872"/>
           </a:xfrm>
           <a:prstGeom prst="ellipse">
             <a:avLst/>
@@ -4078,6 +4981,7 @@
           <a:ln>
             <a:noFill/>
           </a:ln>
+          <a:effectLst/>
         </p:spPr>
         <p:style>
           <a:lnRef idx="1">
@@ -4103,13 +5007,13 @@
       </p:sp>
       <p:sp>
         <p:nvSpPr>
-          <p:cNvPr id="7" name="TextBox 6"/>
+          <p:cNvPr id="12" name="TextBox 11"/>
           <p:cNvSpPr txBox="1"/>
           <p:nvPr/>
         </p:nvSpPr>
         <p:spPr>
           <a:xfrm>
-            <a:off x="868680" y="2212848"/>
+            <a:off x="841248" y="2825496"/>
             <a:ext cx="4937760" cy="365760"/>
           </a:xfrm>
           <a:prstGeom prst="rect">
@@ -4125,7 +5029,7 @@
           <a:p>
             <a:pPr algn="l"/>
             <a:r>
-              <a:rPr sz="1600" b="1">
+              <a:rPr sz="1550" b="1" i="0">
                 <a:solidFill>
                   <a:srgbClr val="FFFFFF"/>
                 </a:solidFill>
@@ -4138,13 +5042,13 @@
       </p:sp>
       <p:sp>
         <p:nvSpPr>
-          <p:cNvPr id="8" name="TextBox 7"/>
+          <p:cNvPr id="13" name="TextBox 12"/>
           <p:cNvSpPr txBox="1"/>
           <p:nvPr/>
         </p:nvSpPr>
         <p:spPr>
           <a:xfrm>
-            <a:off x="868680" y="2560320"/>
+            <a:off x="841248" y="3172968"/>
             <a:ext cx="4937760" cy="457200"/>
           </a:xfrm>
           <a:prstGeom prst="rect">
@@ -4160,7 +5064,7 @@
           <a:p>
             <a:pPr algn="l"/>
             <a:r>
-              <a:rPr sz="1250" b="0">
+              <a:rPr sz="1200" b="0" i="0">
                 <a:solidFill>
                   <a:srgbClr val="9FB0AE"/>
                 </a:solidFill>
@@ -4173,14 +5077,14 @@
       </p:sp>
       <p:sp>
         <p:nvSpPr>
-          <p:cNvPr id="9" name="Oval 8"/>
+          <p:cNvPr id="14" name="Oval 13"/>
           <p:cNvSpPr/>
           <p:nvPr/>
         </p:nvSpPr>
         <p:spPr>
           <a:xfrm>
-            <a:off x="6035040" y="2359152"/>
-            <a:ext cx="128016" cy="128016"/>
+            <a:off x="6035040" y="2962656"/>
+            <a:ext cx="118872" cy="118872"/>
           </a:xfrm>
           <a:prstGeom prst="ellipse">
             <a:avLst/>
@@ -4191,6 +5095,7 @@
           <a:ln>
             <a:noFill/>
           </a:ln>
+          <a:effectLst/>
         </p:spPr>
         <p:style>
           <a:lnRef idx="1">
@@ -4216,13 +5121,13 @@
       </p:sp>
       <p:sp>
         <p:nvSpPr>
-          <p:cNvPr id="10" name="TextBox 9"/>
+          <p:cNvPr id="15" name="TextBox 14"/>
           <p:cNvSpPr txBox="1"/>
           <p:nvPr/>
         </p:nvSpPr>
         <p:spPr>
           <a:xfrm>
-            <a:off x="6355080" y="2212848"/>
+            <a:off x="6327648" y="2825496"/>
             <a:ext cx="4937760" cy="365760"/>
           </a:xfrm>
           <a:prstGeom prst="rect">
@@ -4238,7 +5143,7 @@
           <a:p>
             <a:pPr algn="l"/>
             <a:r>
-              <a:rPr sz="1600" b="1">
+              <a:rPr sz="1550" b="1" i="0">
                 <a:solidFill>
                   <a:srgbClr val="FFFFFF"/>
                 </a:solidFill>
@@ -4251,13 +5156,13 @@
       </p:sp>
       <p:sp>
         <p:nvSpPr>
-          <p:cNvPr id="11" name="TextBox 10"/>
+          <p:cNvPr id="16" name="TextBox 15"/>
           <p:cNvSpPr txBox="1"/>
           <p:nvPr/>
         </p:nvSpPr>
         <p:spPr>
           <a:xfrm>
-            <a:off x="6355080" y="2560320"/>
+            <a:off x="6327648" y="3172968"/>
             <a:ext cx="4937760" cy="457200"/>
           </a:xfrm>
           <a:prstGeom prst="rect">
@@ -4273,7 +5178,7 @@
           <a:p>
             <a:pPr algn="l"/>
             <a:r>
-              <a:rPr sz="1250" b="0">
+              <a:rPr sz="1200" b="0" i="0">
                 <a:solidFill>
                   <a:srgbClr val="9FB0AE"/>
                 </a:solidFill>
@@ -4286,14 +5191,14 @@
       </p:sp>
       <p:sp>
         <p:nvSpPr>
-          <p:cNvPr id="12" name="Oval 11"/>
+          <p:cNvPr id="17" name="Oval 16"/>
           <p:cNvSpPr/>
           <p:nvPr/>
         </p:nvSpPr>
         <p:spPr>
           <a:xfrm>
-            <a:off x="548640" y="3547872"/>
-            <a:ext cx="128016" cy="128016"/>
+            <a:off x="548640" y="4133087"/>
+            <a:ext cx="118872" cy="118872"/>
           </a:xfrm>
           <a:prstGeom prst="ellipse">
             <a:avLst/>
@@ -4304,6 +5209,7 @@
           <a:ln>
             <a:noFill/>
           </a:ln>
+          <a:effectLst/>
         </p:spPr>
         <p:style>
           <a:lnRef idx="1">
@@ -4329,13 +5235,13 @@
       </p:sp>
       <p:sp>
         <p:nvSpPr>
-          <p:cNvPr id="13" name="TextBox 12"/>
+          <p:cNvPr id="18" name="TextBox 17"/>
           <p:cNvSpPr txBox="1"/>
           <p:nvPr/>
         </p:nvSpPr>
         <p:spPr>
           <a:xfrm>
-            <a:off x="868680" y="3401568"/>
+            <a:off x="841248" y="3995927"/>
             <a:ext cx="4937760" cy="365760"/>
           </a:xfrm>
           <a:prstGeom prst="rect">
@@ -4351,7 +5257,7 @@
           <a:p>
             <a:pPr algn="l"/>
             <a:r>
-              <a:rPr sz="1600" b="1">
+              <a:rPr sz="1550" b="1" i="0">
                 <a:solidFill>
                   <a:srgbClr val="FFFFFF"/>
                 </a:solidFill>
@@ -4364,13 +5270,13 @@
       </p:sp>
       <p:sp>
         <p:nvSpPr>
-          <p:cNvPr id="14" name="TextBox 13"/>
+          <p:cNvPr id="19" name="TextBox 18"/>
           <p:cNvSpPr txBox="1"/>
           <p:nvPr/>
         </p:nvSpPr>
         <p:spPr>
           <a:xfrm>
-            <a:off x="868680" y="3749040"/>
+            <a:off x="841248" y="4343399"/>
             <a:ext cx="4937760" cy="457200"/>
           </a:xfrm>
           <a:prstGeom prst="rect">
@@ -4386,7 +5292,7 @@
           <a:p>
             <a:pPr algn="l"/>
             <a:r>
-              <a:rPr sz="1250" b="0">
+              <a:rPr sz="1200" b="0" i="0">
                 <a:solidFill>
                   <a:srgbClr val="9FB0AE"/>
                 </a:solidFill>
@@ -4399,14 +5305,14 @@
       </p:sp>
       <p:sp>
         <p:nvSpPr>
-          <p:cNvPr id="15" name="Oval 14"/>
+          <p:cNvPr id="20" name="Oval 19"/>
           <p:cNvSpPr/>
           <p:nvPr/>
         </p:nvSpPr>
         <p:spPr>
           <a:xfrm>
-            <a:off x="6035040" y="3547872"/>
-            <a:ext cx="128016" cy="128016"/>
+            <a:off x="6035040" y="4133087"/>
+            <a:ext cx="118872" cy="118872"/>
           </a:xfrm>
           <a:prstGeom prst="ellipse">
             <a:avLst/>
@@ -4417,6 +5323,7 @@
           <a:ln>
             <a:noFill/>
           </a:ln>
+          <a:effectLst/>
         </p:spPr>
         <p:style>
           <a:lnRef idx="1">
@@ -4442,13 +5349,13 @@
       </p:sp>
       <p:sp>
         <p:nvSpPr>
-          <p:cNvPr id="16" name="TextBox 15"/>
+          <p:cNvPr id="21" name="TextBox 20"/>
           <p:cNvSpPr txBox="1"/>
           <p:nvPr/>
         </p:nvSpPr>
         <p:spPr>
           <a:xfrm>
-            <a:off x="6355080" y="3401568"/>
+            <a:off x="6327648" y="3995927"/>
             <a:ext cx="4937760" cy="365760"/>
           </a:xfrm>
           <a:prstGeom prst="rect">
@@ -4464,7 +5371,7 @@
           <a:p>
             <a:pPr algn="l"/>
             <a:r>
-              <a:rPr sz="1600" b="1">
+              <a:rPr sz="1550" b="1" i="0">
                 <a:solidFill>
                   <a:srgbClr val="FFFFFF"/>
                 </a:solidFill>
@@ -4477,13 +5384,13 @@
       </p:sp>
       <p:sp>
         <p:nvSpPr>
-          <p:cNvPr id="17" name="TextBox 16"/>
+          <p:cNvPr id="22" name="TextBox 21"/>
           <p:cNvSpPr txBox="1"/>
           <p:nvPr/>
         </p:nvSpPr>
         <p:spPr>
           <a:xfrm>
-            <a:off x="6355080" y="3749040"/>
+            <a:off x="6327648" y="4343399"/>
             <a:ext cx="4937760" cy="457200"/>
           </a:xfrm>
           <a:prstGeom prst="rect">
@@ -4499,7 +5406,7 @@
           <a:p>
             <a:pPr algn="l"/>
             <a:r>
-              <a:rPr sz="1250" b="0">
+              <a:rPr sz="1200" b="0" i="0">
                 <a:solidFill>
                   <a:srgbClr val="9FB0AE"/>
                 </a:solidFill>
@@ -4512,14 +5419,14 @@
       </p:sp>
       <p:sp>
         <p:nvSpPr>
-          <p:cNvPr id="18" name="Oval 17"/>
+          <p:cNvPr id="23" name="Oval 22"/>
           <p:cNvSpPr/>
           <p:nvPr/>
         </p:nvSpPr>
         <p:spPr>
           <a:xfrm>
-            <a:off x="548640" y="4736592"/>
-            <a:ext cx="128016" cy="128016"/>
+            <a:off x="548640" y="5303520"/>
+            <a:ext cx="118872" cy="118872"/>
           </a:xfrm>
           <a:prstGeom prst="ellipse">
             <a:avLst/>
@@ -4530,6 +5437,7 @@
           <a:ln>
             <a:noFill/>
           </a:ln>
+          <a:effectLst/>
         </p:spPr>
         <p:style>
           <a:lnRef idx="1">
@@ -4555,13 +5463,13 @@
       </p:sp>
       <p:sp>
         <p:nvSpPr>
-          <p:cNvPr id="19" name="TextBox 18"/>
+          <p:cNvPr id="24" name="TextBox 23"/>
           <p:cNvSpPr txBox="1"/>
           <p:nvPr/>
         </p:nvSpPr>
         <p:spPr>
           <a:xfrm>
-            <a:off x="868680" y="4590288"/>
+            <a:off x="841248" y="5166360"/>
             <a:ext cx="4937760" cy="365760"/>
           </a:xfrm>
           <a:prstGeom prst="rect">
@@ -4577,7 +5485,7 @@
           <a:p>
             <a:pPr algn="l"/>
             <a:r>
-              <a:rPr sz="1600" b="1">
+              <a:rPr sz="1550" b="1" i="0">
                 <a:solidFill>
                   <a:srgbClr val="FFFFFF"/>
                 </a:solidFill>
@@ -4590,13 +5498,13 @@
       </p:sp>
       <p:sp>
         <p:nvSpPr>
-          <p:cNvPr id="20" name="TextBox 19"/>
+          <p:cNvPr id="25" name="TextBox 24"/>
           <p:cNvSpPr txBox="1"/>
           <p:nvPr/>
         </p:nvSpPr>
         <p:spPr>
           <a:xfrm>
-            <a:off x="868680" y="4937760"/>
+            <a:off x="841248" y="5513832"/>
             <a:ext cx="4937760" cy="457200"/>
           </a:xfrm>
           <a:prstGeom prst="rect">
@@ -4612,7 +5520,7 @@
           <a:p>
             <a:pPr algn="l"/>
             <a:r>
-              <a:rPr sz="1250" b="0">
+              <a:rPr sz="1200" b="0" i="0">
                 <a:solidFill>
                   <a:srgbClr val="9FB0AE"/>
                 </a:solidFill>
@@ -4625,14 +5533,14 @@
       </p:sp>
       <p:sp>
         <p:nvSpPr>
-          <p:cNvPr id="21" name="Oval 20"/>
+          <p:cNvPr id="26" name="Oval 25"/>
           <p:cNvSpPr/>
           <p:nvPr/>
         </p:nvSpPr>
         <p:spPr>
           <a:xfrm>
-            <a:off x="6035040" y="4736592"/>
-            <a:ext cx="128016" cy="128016"/>
+            <a:off x="6035040" y="5303520"/>
+            <a:ext cx="118872" cy="118872"/>
           </a:xfrm>
           <a:prstGeom prst="ellipse">
             <a:avLst/>
@@ -4643,6 +5551,7 @@
           <a:ln>
             <a:noFill/>
           </a:ln>
+          <a:effectLst/>
         </p:spPr>
         <p:style>
           <a:lnRef idx="1">
@@ -4668,13 +5577,13 @@
       </p:sp>
       <p:sp>
         <p:nvSpPr>
-          <p:cNvPr id="22" name="TextBox 21"/>
+          <p:cNvPr id="27" name="TextBox 26"/>
           <p:cNvSpPr txBox="1"/>
           <p:nvPr/>
         </p:nvSpPr>
         <p:spPr>
           <a:xfrm>
-            <a:off x="6355080" y="4590288"/>
+            <a:off x="6327648" y="5166360"/>
             <a:ext cx="4937760" cy="365760"/>
           </a:xfrm>
           <a:prstGeom prst="rect">
@@ -4690,7 +5599,7 @@
           <a:p>
             <a:pPr algn="l"/>
             <a:r>
-              <a:rPr sz="1600" b="1">
+              <a:rPr sz="1550" b="1" i="0">
                 <a:solidFill>
                   <a:srgbClr val="FFFFFF"/>
                 </a:solidFill>
@@ -4703,13 +5612,13 @@
       </p:sp>
       <p:sp>
         <p:nvSpPr>
-          <p:cNvPr id="23" name="TextBox 22"/>
+          <p:cNvPr id="28" name="TextBox 27"/>
           <p:cNvSpPr txBox="1"/>
           <p:nvPr/>
         </p:nvSpPr>
         <p:spPr>
           <a:xfrm>
-            <a:off x="6355080" y="4937760"/>
+            <a:off x="6327648" y="5513832"/>
             <a:ext cx="4937760" cy="457200"/>
           </a:xfrm>
           <a:prstGeom prst="rect">
@@ -4725,13 +5634,48 @@
           <a:p>
             <a:pPr algn="l"/>
             <a:r>
-              <a:rPr sz="1250" b="0">
+              <a:rPr sz="1200" b="0" i="0">
                 <a:solidFill>
                   <a:srgbClr val="9FB0AE"/>
                 </a:solidFill>
                 <a:latin typeface="Calibri"/>
               </a:rPr>
-              <a:t>Narración de video generada con texto a voz</a:t>
+              <a:t>Narración de este video generada con texto a voz</a:t>
+            </a:r>
+          </a:p>
+        </p:txBody>
+      </p:sp>
+      <p:sp>
+        <p:nvSpPr>
+          <p:cNvPr id="29" name="TextBox 28"/>
+          <p:cNvSpPr txBox="1"/>
+          <p:nvPr/>
+        </p:nvSpPr>
+        <p:spPr>
+          <a:xfrm>
+            <a:off x="11247120" y="6446520"/>
+            <a:ext cx="731520" cy="320040"/>
+          </a:xfrm>
+          <a:prstGeom prst="rect">
+            <a:avLst/>
+          </a:prstGeom>
+          <a:noFill/>
+        </p:spPr>
+        <p:txBody>
+          <a:bodyPr wrap="square">
+            <a:spAutoFit/>
+          </a:bodyPr>
+          <a:lstStyle/>
+          <a:p>
+            <a:pPr algn="r"/>
+            <a:r>
+              <a:rPr sz="1100" b="0" i="0">
+                <a:solidFill>
+                  <a:srgbClr val="9FB0AE"/>
+                </a:solidFill>
+                <a:latin typeface="Calibri"/>
+              </a:rPr>
+              <a:t>4/7</a:t>
             </a:r>
           </a:p>
         </p:txBody>
@@ -4806,7 +5750,199 @@
         </p:nvSpPr>
         <p:spPr>
           <a:xfrm>
-            <a:off x="548640" y="457200"/>
+            <a:off x="-2743200" y="-2743200"/>
+            <a:ext cx="8229600" cy="8229600"/>
+          </a:xfrm>
+          <a:prstGeom prst="ellipse">
+            <a:avLst/>
+          </a:prstGeom>
+          <a:solidFill>
+            <a:srgbClr val="142B42"/>
+          </a:solidFill>
+          <a:ln>
+            <a:noFill/>
+          </a:ln>
+          <a:effectLst/>
+        </p:spPr>
+        <p:style>
+          <a:lnRef idx="1">
+            <a:schemeClr val="accent1"/>
+          </a:lnRef>
+          <a:fillRef idx="3">
+            <a:schemeClr val="accent1"/>
+          </a:fillRef>
+          <a:effectRef idx="2">
+            <a:schemeClr val="accent1"/>
+          </a:effectRef>
+          <a:fontRef idx="minor">
+            <a:schemeClr val="lt1"/>
+          </a:fontRef>
+        </p:style>
+        <p:txBody>
+          <a:bodyPr rtlCol="0" anchor="ctr"/>
+          <a:lstStyle/>
+          <a:p>
+            <a:pPr algn="ctr"/>
+          </a:p>
+        </p:txBody>
+      </p:sp>
+      <p:sp>
+        <p:nvSpPr>
+          <p:cNvPr id="4" name="Oval 3"/>
+          <p:cNvSpPr/>
+          <p:nvPr/>
+        </p:nvSpPr>
+        <p:spPr>
+          <a:xfrm>
+            <a:off x="9601200" y="4114800"/>
+            <a:ext cx="5486400" cy="5486400"/>
+          </a:xfrm>
+          <a:prstGeom prst="ellipse">
+            <a:avLst/>
+          </a:prstGeom>
+          <a:solidFill>
+            <a:srgbClr val="142B42"/>
+          </a:solidFill>
+          <a:ln>
+            <a:noFill/>
+          </a:ln>
+          <a:effectLst/>
+        </p:spPr>
+        <p:style>
+          <a:lnRef idx="1">
+            <a:schemeClr val="accent1"/>
+          </a:lnRef>
+          <a:fillRef idx="3">
+            <a:schemeClr val="accent1"/>
+          </a:fillRef>
+          <a:effectRef idx="2">
+            <a:schemeClr val="accent1"/>
+          </a:effectRef>
+          <a:fontRef idx="minor">
+            <a:schemeClr val="lt1"/>
+          </a:fontRef>
+        </p:style>
+        <p:txBody>
+          <a:bodyPr rtlCol="0" anchor="ctr"/>
+          <a:lstStyle/>
+          <a:p>
+            <a:pPr algn="ctr"/>
+          </a:p>
+        </p:txBody>
+      </p:sp>
+      <p:sp>
+        <p:nvSpPr>
+          <p:cNvPr id="5" name="Rounded Rectangle 4"/>
+          <p:cNvSpPr/>
+          <p:nvPr/>
+        </p:nvSpPr>
+        <p:spPr>
+          <a:xfrm>
+            <a:off x="502920" y="365760"/>
+            <a:ext cx="384048" cy="384048"/>
+          </a:xfrm>
+          <a:prstGeom prst="roundRect">
+            <a:avLst>
+              <a:gd name="adj" fmla="val 28000"/>
+            </a:avLst>
+          </a:prstGeom>
+          <a:solidFill>
+            <a:srgbClr val="FFFFFF"/>
+          </a:solidFill>
+          <a:ln>
+            <a:noFill/>
+          </a:ln>
+          <a:effectLst/>
+        </p:spPr>
+        <p:style>
+          <a:lnRef idx="1">
+            <a:schemeClr val="accent1"/>
+          </a:lnRef>
+          <a:fillRef idx="3">
+            <a:schemeClr val="accent1"/>
+          </a:fillRef>
+          <a:effectRef idx="2">
+            <a:schemeClr val="accent1"/>
+          </a:effectRef>
+          <a:fontRef idx="minor">
+            <a:schemeClr val="lt1"/>
+          </a:fontRef>
+        </p:style>
+        <p:txBody>
+          <a:bodyPr rtlCol="0" anchor="ctr"/>
+          <a:lstStyle/>
+          <a:p>
+            <a:pPr algn="ctr"/>
+          </a:p>
+        </p:txBody>
+      </p:sp>
+      <p:pic>
+        <p:nvPicPr>
+          <p:cNvPr id="6" name="Picture 5" descr="logo-icon.png"/>
+          <p:cNvPicPr>
+            <a:picLocks noChangeAspect="1"/>
+          </p:cNvPicPr>
+          <p:nvPr/>
+        </p:nvPicPr>
+        <p:blipFill>
+          <a:blip r:embed="rId2"/>
+          <a:stretch>
+            <a:fillRect/>
+          </a:stretch>
+        </p:blipFill>
+        <p:spPr>
+          <a:xfrm>
+            <a:off x="557784" y="420624"/>
+            <a:ext cx="383084" cy="274320"/>
+          </a:xfrm>
+          <a:prstGeom prst="rect">
+            <a:avLst/>
+          </a:prstGeom>
+        </p:spPr>
+      </p:pic>
+      <p:sp>
+        <p:nvSpPr>
+          <p:cNvPr id="7" name="TextBox 6"/>
+          <p:cNvSpPr txBox="1"/>
+          <p:nvPr/>
+        </p:nvSpPr>
+        <p:spPr>
+          <a:xfrm>
+            <a:off x="987552" y="384048"/>
+            <a:ext cx="3657600" cy="365760"/>
+          </a:xfrm>
+          <a:prstGeom prst="rect">
+            <a:avLst/>
+          </a:prstGeom>
+          <a:noFill/>
+        </p:spPr>
+        <p:txBody>
+          <a:bodyPr wrap="none">
+            <a:spAutoFit/>
+          </a:bodyPr>
+          <a:lstStyle/>
+          <a:p>
+            <a:r>
+              <a:rPr sz="1100" b="1">
+                <a:solidFill>
+                  <a:srgbClr val="9FB0AE"/>
+                </a:solidFill>
+                <a:latin typeface="Calibri"/>
+              </a:rPr>
+              <a:t>REACTIVA TERRITORIO</a:t>
+            </a:r>
+          </a:p>
+        </p:txBody>
+      </p:sp>
+      <p:sp>
+        <p:nvSpPr>
+          <p:cNvPr id="8" name="Oval 7"/>
+          <p:cNvSpPr/>
+          <p:nvPr/>
+        </p:nvSpPr>
+        <p:spPr>
+          <a:xfrm>
+            <a:off x="548640" y="1143000"/>
             <a:ext cx="365760" cy="365760"/>
           </a:xfrm>
           <a:prstGeom prst="ellipse">
@@ -4818,6 +5954,7 @@
           <a:ln>
             <a:noFill/>
           </a:ln>
+          <a:effectLst/>
         </p:spPr>
         <p:style>
           <a:lnRef idx="1">
@@ -4851,13 +5988,13 @@
       </p:sp>
       <p:sp>
         <p:nvSpPr>
-          <p:cNvPr id="4" name="TextBox 3"/>
+          <p:cNvPr id="9" name="TextBox 8"/>
           <p:cNvSpPr txBox="1"/>
           <p:nvPr/>
         </p:nvSpPr>
         <p:spPr>
           <a:xfrm>
-            <a:off x="1051560" y="475488"/>
+            <a:off x="1051560" y="1161288"/>
             <a:ext cx="5486400" cy="365760"/>
           </a:xfrm>
           <a:prstGeom prst="rect">
@@ -4873,7 +6010,7 @@
           <a:p>
             <a:pPr algn="l"/>
             <a:r>
-              <a:rPr sz="1300" b="1">
+              <a:rPr sz="1300" b="1" i="0">
                 <a:solidFill>
                   <a:srgbClr val="14B8A8"/>
                 </a:solidFill>
@@ -4886,13 +6023,13 @@
       </p:sp>
       <p:sp>
         <p:nvSpPr>
-          <p:cNvPr id="5" name="TextBox 4"/>
+          <p:cNvPr id="10" name="TextBox 9"/>
           <p:cNvSpPr txBox="1"/>
           <p:nvPr/>
         </p:nvSpPr>
         <p:spPr>
           <a:xfrm>
-            <a:off x="548640" y="1005840"/>
+            <a:off x="548640" y="1691640"/>
             <a:ext cx="10515600" cy="1097280"/>
           </a:xfrm>
           <a:prstGeom prst="rect">
@@ -4908,7 +6045,7 @@
           <a:p>
             <a:pPr algn="l"/>
             <a:r>
-              <a:rPr sz="3400" b="1">
+              <a:rPr sz="3300" b="1" i="0">
                 <a:solidFill>
                   <a:srgbClr val="FFFFFF"/>
                 </a:solidFill>
@@ -4921,13 +6058,13 @@
       </p:sp>
       <p:sp>
         <p:nvSpPr>
-          <p:cNvPr id="6" name="TextBox 5"/>
+          <p:cNvPr id="11" name="TextBox 10"/>
           <p:cNvSpPr txBox="1"/>
           <p:nvPr/>
         </p:nvSpPr>
         <p:spPr>
           <a:xfrm>
-            <a:off x="548640" y="1920240"/>
+            <a:off x="548640" y="2606040"/>
             <a:ext cx="9601200" cy="731520"/>
           </a:xfrm>
           <a:prstGeom prst="rect">
@@ -4943,7 +6080,7 @@
           <a:p>
             <a:pPr algn="l"/>
             <a:r>
-              <a:rPr sz="1700" b="0">
+              <a:rPr sz="1600" b="0" i="0">
                 <a:solidFill>
                   <a:srgbClr val="9FB0AE"/>
                 </a:solidFill>
@@ -4956,17 +6093,19 @@
       </p:sp>
       <p:sp>
         <p:nvSpPr>
-          <p:cNvPr id="7" name="Rounded Rectangle 6"/>
+          <p:cNvPr id="12" name="Rounded Rectangle 11"/>
           <p:cNvSpPr/>
           <p:nvPr/>
         </p:nvSpPr>
         <p:spPr>
           <a:xfrm>
-            <a:off x="548640" y="2834640"/>
-            <a:ext cx="6583680" cy="822960"/>
+            <a:off x="548640" y="3520440"/>
+            <a:ext cx="6675120" cy="868680"/>
           </a:xfrm>
           <a:prstGeom prst="roundRect">
-            <a:avLst/>
+            <a:avLst>
+              <a:gd name="adj" fmla="val 8000"/>
+            </a:avLst>
           </a:prstGeom>
           <a:solidFill>
             <a:srgbClr val="162A47"/>
@@ -4976,6 +6115,7 @@
               <a:srgbClr val="273C5C"/>
             </a:solidFill>
           </a:ln>
+          <a:effectLst/>
         </p:spPr>
         <p:style>
           <a:lnRef idx="1">
@@ -4997,6 +6137,14 @@
           <a:p>
             <a:pPr algn="ctr"/>
             <a:r>
+              <a:rPr sz="1400">
+                <a:solidFill>
+                  <a:srgbClr val="14B8A8"/>
+                </a:solidFill>
+              </a:rPr>
+              <a:t>●  </a:t>
+            </a:r>
+            <a:r>
               <a:rPr sz="2400" b="1">
                 <a:solidFill>
                   <a:srgbClr val="FFFFFF"/>
@@ -5010,13 +6158,13 @@
       </p:sp>
       <p:sp>
         <p:nvSpPr>
-          <p:cNvPr id="8" name="TextBox 7"/>
+          <p:cNvPr id="13" name="TextBox 12"/>
           <p:cNvSpPr txBox="1"/>
           <p:nvPr/>
         </p:nvSpPr>
         <p:spPr>
           <a:xfrm>
-            <a:off x="548640" y="3931920"/>
+            <a:off x="548640" y="4663440"/>
             <a:ext cx="10058400" cy="731520"/>
           </a:xfrm>
           <a:prstGeom prst="rect">
@@ -5032,13 +6180,48 @@
           <a:p>
             <a:pPr algn="l"/>
             <a:r>
-              <a:rPr sz="1400" b="0">
+              <a:rPr sz="1350" b="0" i="0">
                 <a:solidFill>
                   <a:srgbClr val="9FB0AE"/>
                 </a:solidFill>
                 <a:latin typeface="Calibri"/>
               </a:rPr>
-              <a:t>Cuentas demo: lider@demo.reactiva · org@demo.reactiva · admin@demo.reactiva  —  contraseña: demo1234</a:t>
+              <a:t>Cuentas demo: lider@demo.reactiva  ·  org@demo.reactiva  ·  admin@demo.reactiva   —   contraseña: demo1234</a:t>
+            </a:r>
+          </a:p>
+        </p:txBody>
+      </p:sp>
+      <p:sp>
+        <p:nvSpPr>
+          <p:cNvPr id="14" name="TextBox 13"/>
+          <p:cNvSpPr txBox="1"/>
+          <p:nvPr/>
+        </p:nvSpPr>
+        <p:spPr>
+          <a:xfrm>
+            <a:off x="11247120" y="6446520"/>
+            <a:ext cx="731520" cy="320040"/>
+          </a:xfrm>
+          <a:prstGeom prst="rect">
+            <a:avLst/>
+          </a:prstGeom>
+          <a:noFill/>
+        </p:spPr>
+        <p:txBody>
+          <a:bodyPr wrap="square">
+            <a:spAutoFit/>
+          </a:bodyPr>
+          <a:lstStyle/>
+          <a:p>
+            <a:pPr algn="r"/>
+            <a:r>
+              <a:rPr sz="1100" b="0" i="0">
+                <a:solidFill>
+                  <a:srgbClr val="9FB0AE"/>
+                </a:solidFill>
+                <a:latin typeface="Calibri"/>
+              </a:rPr>
+              <a:t>5/7</a:t>
             </a:r>
           </a:p>
         </p:txBody>
@@ -5113,7 +6296,199 @@
         </p:nvSpPr>
         <p:spPr>
           <a:xfrm>
-            <a:off x="548640" y="457200"/>
+            <a:off x="-2743200" y="-2743200"/>
+            <a:ext cx="8229600" cy="8229600"/>
+          </a:xfrm>
+          <a:prstGeom prst="ellipse">
+            <a:avLst/>
+          </a:prstGeom>
+          <a:solidFill>
+            <a:srgbClr val="142B42"/>
+          </a:solidFill>
+          <a:ln>
+            <a:noFill/>
+          </a:ln>
+          <a:effectLst/>
+        </p:spPr>
+        <p:style>
+          <a:lnRef idx="1">
+            <a:schemeClr val="accent1"/>
+          </a:lnRef>
+          <a:fillRef idx="3">
+            <a:schemeClr val="accent1"/>
+          </a:fillRef>
+          <a:effectRef idx="2">
+            <a:schemeClr val="accent1"/>
+          </a:effectRef>
+          <a:fontRef idx="minor">
+            <a:schemeClr val="lt1"/>
+          </a:fontRef>
+        </p:style>
+        <p:txBody>
+          <a:bodyPr rtlCol="0" anchor="ctr"/>
+          <a:lstStyle/>
+          <a:p>
+            <a:pPr algn="ctr"/>
+          </a:p>
+        </p:txBody>
+      </p:sp>
+      <p:sp>
+        <p:nvSpPr>
+          <p:cNvPr id="4" name="Oval 3"/>
+          <p:cNvSpPr/>
+          <p:nvPr/>
+        </p:nvSpPr>
+        <p:spPr>
+          <a:xfrm>
+            <a:off x="9601200" y="4114800"/>
+            <a:ext cx="5486400" cy="5486400"/>
+          </a:xfrm>
+          <a:prstGeom prst="ellipse">
+            <a:avLst/>
+          </a:prstGeom>
+          <a:solidFill>
+            <a:srgbClr val="142B42"/>
+          </a:solidFill>
+          <a:ln>
+            <a:noFill/>
+          </a:ln>
+          <a:effectLst/>
+        </p:spPr>
+        <p:style>
+          <a:lnRef idx="1">
+            <a:schemeClr val="accent1"/>
+          </a:lnRef>
+          <a:fillRef idx="3">
+            <a:schemeClr val="accent1"/>
+          </a:fillRef>
+          <a:effectRef idx="2">
+            <a:schemeClr val="accent1"/>
+          </a:effectRef>
+          <a:fontRef idx="minor">
+            <a:schemeClr val="lt1"/>
+          </a:fontRef>
+        </p:style>
+        <p:txBody>
+          <a:bodyPr rtlCol="0" anchor="ctr"/>
+          <a:lstStyle/>
+          <a:p>
+            <a:pPr algn="ctr"/>
+          </a:p>
+        </p:txBody>
+      </p:sp>
+      <p:sp>
+        <p:nvSpPr>
+          <p:cNvPr id="5" name="Rounded Rectangle 4"/>
+          <p:cNvSpPr/>
+          <p:nvPr/>
+        </p:nvSpPr>
+        <p:spPr>
+          <a:xfrm>
+            <a:off x="502920" y="365760"/>
+            <a:ext cx="384048" cy="384048"/>
+          </a:xfrm>
+          <a:prstGeom prst="roundRect">
+            <a:avLst>
+              <a:gd name="adj" fmla="val 28000"/>
+            </a:avLst>
+          </a:prstGeom>
+          <a:solidFill>
+            <a:srgbClr val="FFFFFF"/>
+          </a:solidFill>
+          <a:ln>
+            <a:noFill/>
+          </a:ln>
+          <a:effectLst/>
+        </p:spPr>
+        <p:style>
+          <a:lnRef idx="1">
+            <a:schemeClr val="accent1"/>
+          </a:lnRef>
+          <a:fillRef idx="3">
+            <a:schemeClr val="accent1"/>
+          </a:fillRef>
+          <a:effectRef idx="2">
+            <a:schemeClr val="accent1"/>
+          </a:effectRef>
+          <a:fontRef idx="minor">
+            <a:schemeClr val="lt1"/>
+          </a:fontRef>
+        </p:style>
+        <p:txBody>
+          <a:bodyPr rtlCol="0" anchor="ctr"/>
+          <a:lstStyle/>
+          <a:p>
+            <a:pPr algn="ctr"/>
+          </a:p>
+        </p:txBody>
+      </p:sp>
+      <p:pic>
+        <p:nvPicPr>
+          <p:cNvPr id="6" name="Picture 5" descr="logo-icon.png"/>
+          <p:cNvPicPr>
+            <a:picLocks noChangeAspect="1"/>
+          </p:cNvPicPr>
+          <p:nvPr/>
+        </p:nvPicPr>
+        <p:blipFill>
+          <a:blip r:embed="rId2"/>
+          <a:stretch>
+            <a:fillRect/>
+          </a:stretch>
+        </p:blipFill>
+        <p:spPr>
+          <a:xfrm>
+            <a:off x="557784" y="420624"/>
+            <a:ext cx="383084" cy="274320"/>
+          </a:xfrm>
+          <a:prstGeom prst="rect">
+            <a:avLst/>
+          </a:prstGeom>
+        </p:spPr>
+      </p:pic>
+      <p:sp>
+        <p:nvSpPr>
+          <p:cNvPr id="7" name="TextBox 6"/>
+          <p:cNvSpPr txBox="1"/>
+          <p:nvPr/>
+        </p:nvSpPr>
+        <p:spPr>
+          <a:xfrm>
+            <a:off x="987552" y="384048"/>
+            <a:ext cx="3657600" cy="365760"/>
+          </a:xfrm>
+          <a:prstGeom prst="rect">
+            <a:avLst/>
+          </a:prstGeom>
+          <a:noFill/>
+        </p:spPr>
+        <p:txBody>
+          <a:bodyPr wrap="none">
+            <a:spAutoFit/>
+          </a:bodyPr>
+          <a:lstStyle/>
+          <a:p>
+            <a:r>
+              <a:rPr sz="1100" b="1">
+                <a:solidFill>
+                  <a:srgbClr val="9FB0AE"/>
+                </a:solidFill>
+                <a:latin typeface="Calibri"/>
+              </a:rPr>
+              <a:t>REACTIVA TERRITORIO</a:t>
+            </a:r>
+          </a:p>
+        </p:txBody>
+      </p:sp>
+      <p:sp>
+        <p:nvSpPr>
+          <p:cNvPr id="8" name="Oval 7"/>
+          <p:cNvSpPr/>
+          <p:nvPr/>
+        </p:nvSpPr>
+        <p:spPr>
+          <a:xfrm>
+            <a:off x="548640" y="1143000"/>
             <a:ext cx="365760" cy="365760"/>
           </a:xfrm>
           <a:prstGeom prst="ellipse">
@@ -5125,6 +6500,7 @@
           <a:ln>
             <a:noFill/>
           </a:ln>
+          <a:effectLst/>
         </p:spPr>
         <p:style>
           <a:lnRef idx="1">
@@ -5158,13 +6534,13 @@
       </p:sp>
       <p:sp>
         <p:nvSpPr>
-          <p:cNvPr id="4" name="TextBox 3"/>
+          <p:cNvPr id="9" name="TextBox 8"/>
           <p:cNvSpPr txBox="1"/>
           <p:nvPr/>
         </p:nvSpPr>
         <p:spPr>
           <a:xfrm>
-            <a:off x="1051560" y="475488"/>
+            <a:off x="1051560" y="1161288"/>
             <a:ext cx="5486400" cy="365760"/>
           </a:xfrm>
           <a:prstGeom prst="rect">
@@ -5180,7 +6556,7 @@
           <a:p>
             <a:pPr algn="l"/>
             <a:r>
-              <a:rPr sz="1300" b="1">
+              <a:rPr sz="1300" b="1" i="0">
                 <a:solidFill>
                   <a:srgbClr val="14B8A8"/>
                 </a:solidFill>
@@ -5193,13 +6569,13 @@
       </p:sp>
       <p:sp>
         <p:nvSpPr>
-          <p:cNvPr id="5" name="TextBox 4"/>
+          <p:cNvPr id="10" name="TextBox 9"/>
           <p:cNvSpPr txBox="1"/>
           <p:nvPr/>
         </p:nvSpPr>
         <p:spPr>
           <a:xfrm>
-            <a:off x="548640" y="1005840"/>
+            <a:off x="548640" y="1691640"/>
             <a:ext cx="10515600" cy="1097280"/>
           </a:xfrm>
           <a:prstGeom prst="rect">
@@ -5215,7 +6591,7 @@
           <a:p>
             <a:pPr algn="l"/>
             <a:r>
-              <a:rPr sz="3400" b="1">
+              <a:rPr sz="3300" b="1" i="0">
                 <a:solidFill>
                   <a:srgbClr val="FFFFFF"/>
                 </a:solidFill>
@@ -5228,17 +6604,19 @@
       </p:sp>
       <p:sp>
         <p:nvSpPr>
-          <p:cNvPr id="6" name="Rounded Rectangle 5"/>
+          <p:cNvPr id="11" name="Rounded Rectangle 10"/>
           <p:cNvSpPr/>
           <p:nvPr/>
         </p:nvSpPr>
         <p:spPr>
           <a:xfrm>
-            <a:off x="548640" y="2103120"/>
-            <a:ext cx="8686800" cy="822960"/>
+            <a:off x="548640" y="2743200"/>
+            <a:ext cx="8778240" cy="868680"/>
           </a:xfrm>
           <a:prstGeom prst="roundRect">
-            <a:avLst/>
+            <a:avLst>
+              <a:gd name="adj" fmla="val 8000"/>
+            </a:avLst>
           </a:prstGeom>
           <a:solidFill>
             <a:srgbClr val="162A47"/>
@@ -5248,6 +6626,7 @@
               <a:srgbClr val="273C5C"/>
             </a:solidFill>
           </a:ln>
+          <a:effectLst/>
         </p:spPr>
         <p:style>
           <a:lnRef idx="1">
@@ -5269,7 +6648,15 @@
           <a:p>
             <a:pPr algn="ctr"/>
             <a:r>
-              <a:rPr sz="2000" b="1">
+              <a:rPr sz="1200">
+                <a:solidFill>
+                  <a:srgbClr val="14B8A8"/>
+                </a:solidFill>
+              </a:rPr>
+              <a:t>●  </a:t>
+            </a:r>
+            <a:r>
+              <a:rPr sz="1900" b="1">
                 <a:solidFill>
                   <a:srgbClr val="FFFFFF"/>
                 </a:solidFill>
@@ -5282,13 +6669,13 @@
       </p:sp>
       <p:sp>
         <p:nvSpPr>
-          <p:cNvPr id="7" name="TextBox 6"/>
+          <p:cNvPr id="12" name="TextBox 11"/>
           <p:cNvSpPr txBox="1"/>
           <p:nvPr/>
         </p:nvSpPr>
         <p:spPr>
           <a:xfrm>
-            <a:off x="548640" y="3291840"/>
+            <a:off x="548640" y="3977639"/>
             <a:ext cx="3383280" cy="640080"/>
           </a:xfrm>
           <a:prstGeom prst="rect">
@@ -5304,7 +6691,7 @@
           <a:p>
             <a:pPr algn="l"/>
             <a:r>
-              <a:rPr sz="3000" b="1">
+              <a:rPr sz="2800" b="1" i="0">
                 <a:solidFill>
                   <a:srgbClr val="FFFFFF"/>
                 </a:solidFill>
@@ -5317,13 +6704,13 @@
       </p:sp>
       <p:sp>
         <p:nvSpPr>
-          <p:cNvPr id="8" name="TextBox 7"/>
+          <p:cNvPr id="13" name="TextBox 12"/>
           <p:cNvSpPr txBox="1"/>
           <p:nvPr/>
         </p:nvSpPr>
         <p:spPr>
           <a:xfrm>
-            <a:off x="548640" y="3977639"/>
+            <a:off x="548640" y="4617720"/>
             <a:ext cx="3383280" cy="731520"/>
           </a:xfrm>
           <a:prstGeom prst="rect">
@@ -5339,7 +6726,7 @@
           <a:p>
             <a:pPr algn="l"/>
             <a:r>
-              <a:rPr sz="1300" b="0">
+              <a:rPr sz="1250" b="0" i="0">
                 <a:solidFill>
                   <a:srgbClr val="9FB0AE"/>
                 </a:solidFill>
@@ -5352,13 +6739,13 @@
       </p:sp>
       <p:sp>
         <p:nvSpPr>
-          <p:cNvPr id="9" name="TextBox 8"/>
+          <p:cNvPr id="14" name="TextBox 13"/>
           <p:cNvSpPr txBox="1"/>
           <p:nvPr/>
         </p:nvSpPr>
         <p:spPr>
           <a:xfrm>
-            <a:off x="4206240" y="3291840"/>
+            <a:off x="4206240" y="3977639"/>
             <a:ext cx="3383280" cy="640080"/>
           </a:xfrm>
           <a:prstGeom prst="rect">
@@ -5374,7 +6761,7 @@
           <a:p>
             <a:pPr algn="l"/>
             <a:r>
-              <a:rPr sz="3000" b="1">
+              <a:rPr sz="2800" b="1" i="0">
                 <a:solidFill>
                   <a:srgbClr val="FFFFFF"/>
                 </a:solidFill>
@@ -5387,13 +6774,13 @@
       </p:sp>
       <p:sp>
         <p:nvSpPr>
-          <p:cNvPr id="10" name="TextBox 9"/>
+          <p:cNvPr id="15" name="TextBox 14"/>
           <p:cNvSpPr txBox="1"/>
           <p:nvPr/>
         </p:nvSpPr>
         <p:spPr>
           <a:xfrm>
-            <a:off x="4206240" y="3977639"/>
+            <a:off x="4206240" y="4617720"/>
             <a:ext cx="3383280" cy="731520"/>
           </a:xfrm>
           <a:prstGeom prst="rect">
@@ -5409,7 +6796,7 @@
           <a:p>
             <a:pPr algn="l"/>
             <a:r>
-              <a:rPr sz="1300" b="0">
+              <a:rPr sz="1250" b="0" i="0">
                 <a:solidFill>
                   <a:srgbClr val="9FB0AE"/>
                 </a:solidFill>
@@ -5422,13 +6809,13 @@
       </p:sp>
       <p:sp>
         <p:nvSpPr>
-          <p:cNvPr id="11" name="TextBox 10"/>
+          <p:cNvPr id="16" name="TextBox 15"/>
           <p:cNvSpPr txBox="1"/>
           <p:nvPr/>
         </p:nvSpPr>
         <p:spPr>
           <a:xfrm>
-            <a:off x="7863840" y="3291840"/>
+            <a:off x="7863840" y="3977639"/>
             <a:ext cx="3383280" cy="640080"/>
           </a:xfrm>
           <a:prstGeom prst="rect">
@@ -5444,7 +6831,7 @@
           <a:p>
             <a:pPr algn="l"/>
             <a:r>
-              <a:rPr sz="3000" b="1">
+              <a:rPr sz="2800" b="1" i="0">
                 <a:solidFill>
                   <a:srgbClr val="FFFFFF"/>
                 </a:solidFill>
@@ -5457,13 +6844,13 @@
       </p:sp>
       <p:sp>
         <p:nvSpPr>
-          <p:cNvPr id="12" name="TextBox 11"/>
+          <p:cNvPr id="17" name="TextBox 16"/>
           <p:cNvSpPr txBox="1"/>
           <p:nvPr/>
         </p:nvSpPr>
         <p:spPr>
           <a:xfrm>
-            <a:off x="7863840" y="3977639"/>
+            <a:off x="7863840" y="4617720"/>
             <a:ext cx="3383280" cy="731520"/>
           </a:xfrm>
           <a:prstGeom prst="rect">
@@ -5479,13 +6866,48 @@
           <a:p>
             <a:pPr algn="l"/>
             <a:r>
-              <a:rPr sz="1300" b="0">
+              <a:rPr sz="1250" b="0" i="0">
                 <a:solidFill>
                   <a:srgbClr val="9FB0AE"/>
                 </a:solidFill>
                 <a:latin typeface="Calibri"/>
               </a:rPr>
               <a:t>reglas de seguridad reales en Firestore</a:t>
+            </a:r>
+          </a:p>
+        </p:txBody>
+      </p:sp>
+      <p:sp>
+        <p:nvSpPr>
+          <p:cNvPr id="18" name="TextBox 17"/>
+          <p:cNvSpPr txBox="1"/>
+          <p:nvPr/>
+        </p:nvSpPr>
+        <p:spPr>
+          <a:xfrm>
+            <a:off x="11247120" y="6446520"/>
+            <a:ext cx="731520" cy="320040"/>
+          </a:xfrm>
+          <a:prstGeom prst="rect">
+            <a:avLst/>
+          </a:prstGeom>
+          <a:noFill/>
+        </p:spPr>
+        <p:txBody>
+          <a:bodyPr wrap="square">
+            <a:spAutoFit/>
+          </a:bodyPr>
+          <a:lstStyle/>
+          <a:p>
+            <a:pPr algn="r"/>
+            <a:r>
+              <a:rPr sz="1100" b="0" i="0">
+                <a:solidFill>
+                  <a:srgbClr val="9FB0AE"/>
+                </a:solidFill>
+                <a:latin typeface="Calibri"/>
+              </a:rPr>
+              <a:t>6/7</a:t>
             </a:r>
           </a:p>
         </p:txBody>
@@ -5560,7 +6982,199 @@
         </p:nvSpPr>
         <p:spPr>
           <a:xfrm>
-            <a:off x="548640" y="457200"/>
+            <a:off x="-2743200" y="-2743200"/>
+            <a:ext cx="8229600" cy="8229600"/>
+          </a:xfrm>
+          <a:prstGeom prst="ellipse">
+            <a:avLst/>
+          </a:prstGeom>
+          <a:solidFill>
+            <a:srgbClr val="142B42"/>
+          </a:solidFill>
+          <a:ln>
+            <a:noFill/>
+          </a:ln>
+          <a:effectLst/>
+        </p:spPr>
+        <p:style>
+          <a:lnRef idx="1">
+            <a:schemeClr val="accent1"/>
+          </a:lnRef>
+          <a:fillRef idx="3">
+            <a:schemeClr val="accent1"/>
+          </a:fillRef>
+          <a:effectRef idx="2">
+            <a:schemeClr val="accent1"/>
+          </a:effectRef>
+          <a:fontRef idx="minor">
+            <a:schemeClr val="lt1"/>
+          </a:fontRef>
+        </p:style>
+        <p:txBody>
+          <a:bodyPr rtlCol="0" anchor="ctr"/>
+          <a:lstStyle/>
+          <a:p>
+            <a:pPr algn="ctr"/>
+          </a:p>
+        </p:txBody>
+      </p:sp>
+      <p:sp>
+        <p:nvSpPr>
+          <p:cNvPr id="4" name="Oval 3"/>
+          <p:cNvSpPr/>
+          <p:nvPr/>
+        </p:nvSpPr>
+        <p:spPr>
+          <a:xfrm>
+            <a:off x="9601200" y="4114800"/>
+            <a:ext cx="5486400" cy="5486400"/>
+          </a:xfrm>
+          <a:prstGeom prst="ellipse">
+            <a:avLst/>
+          </a:prstGeom>
+          <a:solidFill>
+            <a:srgbClr val="142B42"/>
+          </a:solidFill>
+          <a:ln>
+            <a:noFill/>
+          </a:ln>
+          <a:effectLst/>
+        </p:spPr>
+        <p:style>
+          <a:lnRef idx="1">
+            <a:schemeClr val="accent1"/>
+          </a:lnRef>
+          <a:fillRef idx="3">
+            <a:schemeClr val="accent1"/>
+          </a:fillRef>
+          <a:effectRef idx="2">
+            <a:schemeClr val="accent1"/>
+          </a:effectRef>
+          <a:fontRef idx="minor">
+            <a:schemeClr val="lt1"/>
+          </a:fontRef>
+        </p:style>
+        <p:txBody>
+          <a:bodyPr rtlCol="0" anchor="ctr"/>
+          <a:lstStyle/>
+          <a:p>
+            <a:pPr algn="ctr"/>
+          </a:p>
+        </p:txBody>
+      </p:sp>
+      <p:sp>
+        <p:nvSpPr>
+          <p:cNvPr id="5" name="Rounded Rectangle 4"/>
+          <p:cNvSpPr/>
+          <p:nvPr/>
+        </p:nvSpPr>
+        <p:spPr>
+          <a:xfrm>
+            <a:off x="502920" y="365760"/>
+            <a:ext cx="384048" cy="384048"/>
+          </a:xfrm>
+          <a:prstGeom prst="roundRect">
+            <a:avLst>
+              <a:gd name="adj" fmla="val 28000"/>
+            </a:avLst>
+          </a:prstGeom>
+          <a:solidFill>
+            <a:srgbClr val="FFFFFF"/>
+          </a:solidFill>
+          <a:ln>
+            <a:noFill/>
+          </a:ln>
+          <a:effectLst/>
+        </p:spPr>
+        <p:style>
+          <a:lnRef idx="1">
+            <a:schemeClr val="accent1"/>
+          </a:lnRef>
+          <a:fillRef idx="3">
+            <a:schemeClr val="accent1"/>
+          </a:fillRef>
+          <a:effectRef idx="2">
+            <a:schemeClr val="accent1"/>
+          </a:effectRef>
+          <a:fontRef idx="minor">
+            <a:schemeClr val="lt1"/>
+          </a:fontRef>
+        </p:style>
+        <p:txBody>
+          <a:bodyPr rtlCol="0" anchor="ctr"/>
+          <a:lstStyle/>
+          <a:p>
+            <a:pPr algn="ctr"/>
+          </a:p>
+        </p:txBody>
+      </p:sp>
+      <p:pic>
+        <p:nvPicPr>
+          <p:cNvPr id="6" name="Picture 5" descr="logo-icon.png"/>
+          <p:cNvPicPr>
+            <a:picLocks noChangeAspect="1"/>
+          </p:cNvPicPr>
+          <p:nvPr/>
+        </p:nvPicPr>
+        <p:blipFill>
+          <a:blip r:embed="rId2"/>
+          <a:stretch>
+            <a:fillRect/>
+          </a:stretch>
+        </p:blipFill>
+        <p:spPr>
+          <a:xfrm>
+            <a:off x="557784" y="420624"/>
+            <a:ext cx="383084" cy="274320"/>
+          </a:xfrm>
+          <a:prstGeom prst="rect">
+            <a:avLst/>
+          </a:prstGeom>
+        </p:spPr>
+      </p:pic>
+      <p:sp>
+        <p:nvSpPr>
+          <p:cNvPr id="7" name="TextBox 6"/>
+          <p:cNvSpPr txBox="1"/>
+          <p:nvPr/>
+        </p:nvSpPr>
+        <p:spPr>
+          <a:xfrm>
+            <a:off x="987552" y="384048"/>
+            <a:ext cx="3657600" cy="365760"/>
+          </a:xfrm>
+          <a:prstGeom prst="rect">
+            <a:avLst/>
+          </a:prstGeom>
+          <a:noFill/>
+        </p:spPr>
+        <p:txBody>
+          <a:bodyPr wrap="none">
+            <a:spAutoFit/>
+          </a:bodyPr>
+          <a:lstStyle/>
+          <a:p>
+            <a:r>
+              <a:rPr sz="1100" b="1">
+                <a:solidFill>
+                  <a:srgbClr val="9FB0AE"/>
+                </a:solidFill>
+                <a:latin typeface="Calibri"/>
+              </a:rPr>
+              <a:t>REACTIVA TERRITORIO</a:t>
+            </a:r>
+          </a:p>
+        </p:txBody>
+      </p:sp>
+      <p:sp>
+        <p:nvSpPr>
+          <p:cNvPr id="8" name="Oval 7"/>
+          <p:cNvSpPr/>
+          <p:nvPr/>
+        </p:nvSpPr>
+        <p:spPr>
+          <a:xfrm>
+            <a:off x="548640" y="1143000"/>
             <a:ext cx="365760" cy="365760"/>
           </a:xfrm>
           <a:prstGeom prst="ellipse">
@@ -5572,6 +7186,7 @@
           <a:ln>
             <a:noFill/>
           </a:ln>
+          <a:effectLst/>
         </p:spPr>
         <p:style>
           <a:lnRef idx="1">
@@ -5605,13 +7220,13 @@
       </p:sp>
       <p:sp>
         <p:nvSpPr>
-          <p:cNvPr id="4" name="TextBox 3"/>
+          <p:cNvPr id="9" name="TextBox 8"/>
           <p:cNvSpPr txBox="1"/>
           <p:nvPr/>
         </p:nvSpPr>
         <p:spPr>
           <a:xfrm>
-            <a:off x="1051560" y="475488"/>
+            <a:off x="1051560" y="1161288"/>
             <a:ext cx="5486400" cy="365760"/>
           </a:xfrm>
           <a:prstGeom prst="rect">
@@ -5627,7 +7242,7 @@
           <a:p>
             <a:pPr algn="l"/>
             <a:r>
-              <a:rPr sz="1300" b="1">
+              <a:rPr sz="1300" b="1" i="0">
                 <a:solidFill>
                   <a:srgbClr val="14B8A8"/>
                 </a:solidFill>
@@ -5640,13 +7255,13 @@
       </p:sp>
       <p:sp>
         <p:nvSpPr>
-          <p:cNvPr id="5" name="TextBox 4"/>
+          <p:cNvPr id="10" name="TextBox 9"/>
           <p:cNvSpPr txBox="1"/>
           <p:nvPr/>
         </p:nvSpPr>
         <p:spPr>
           <a:xfrm>
-            <a:off x="548640" y="1005840"/>
+            <a:off x="548640" y="1691640"/>
             <a:ext cx="10515600" cy="1097280"/>
           </a:xfrm>
           <a:prstGeom prst="rect">
@@ -5662,7 +7277,7 @@
           <a:p>
             <a:pPr algn="l"/>
             <a:r>
-              <a:rPr sz="3400" b="1">
+              <a:rPr sz="3300" b="1" i="0">
                 <a:solidFill>
                   <a:srgbClr val="FFFFFF"/>
                 </a:solidFill>
@@ -5675,13 +7290,13 @@
       </p:sp>
       <p:sp>
         <p:nvSpPr>
-          <p:cNvPr id="6" name="TextBox 5"/>
+          <p:cNvPr id="11" name="TextBox 10"/>
           <p:cNvSpPr txBox="1"/>
           <p:nvPr/>
         </p:nvSpPr>
         <p:spPr>
           <a:xfrm>
-            <a:off x="548640" y="1920240"/>
+            <a:off x="548640" y="2606040"/>
             <a:ext cx="9601200" cy="731520"/>
           </a:xfrm>
           <a:prstGeom prst="rect">
@@ -5697,7 +7312,7 @@
           <a:p>
             <a:pPr algn="l"/>
             <a:r>
-              <a:rPr sz="1700" b="0">
+              <a:rPr sz="1600" b="0" i="0">
                 <a:solidFill>
                   <a:srgbClr val="9FB0AE"/>
                 </a:solidFill>
@@ -5710,13 +7325,13 @@
       </p:sp>
       <p:sp>
         <p:nvSpPr>
-          <p:cNvPr id="7" name="TextBox 6"/>
+          <p:cNvPr id="12" name="TextBox 11"/>
           <p:cNvSpPr txBox="1"/>
           <p:nvPr/>
         </p:nvSpPr>
         <p:spPr>
           <a:xfrm>
-            <a:off x="548640" y="3017520"/>
+            <a:off x="548640" y="3566160"/>
             <a:ext cx="2468880" cy="640080"/>
           </a:xfrm>
           <a:prstGeom prst="rect">
@@ -5732,7 +7347,7 @@
           <a:p>
             <a:pPr algn="l"/>
             <a:r>
-              <a:rPr sz="2600" b="1">
+              <a:rPr sz="2600" b="1" i="0">
                 <a:solidFill>
                   <a:srgbClr val="FFFFFF"/>
                 </a:solidFill>
@@ -5745,13 +7360,13 @@
       </p:sp>
       <p:sp>
         <p:nvSpPr>
-          <p:cNvPr id="8" name="TextBox 7"/>
+          <p:cNvPr id="13" name="TextBox 12"/>
           <p:cNvSpPr txBox="1"/>
           <p:nvPr/>
         </p:nvSpPr>
         <p:spPr>
           <a:xfrm>
-            <a:off x="548640" y="3611880"/>
+            <a:off x="548640" y="4160520"/>
             <a:ext cx="2468880" cy="822960"/>
           </a:xfrm>
           <a:prstGeom prst="rect">
@@ -5765,9 +7380,8 @@
           </a:bodyPr>
           <a:lstStyle/>
           <a:p>
-            <a:pPr algn="l"/>
-            <a:r>
-              <a:rPr sz="1200" b="0">
+            <a:r>
+              <a:rPr sz="1200">
                 <a:solidFill>
                   <a:srgbClr val="9FB0AE"/>
                 </a:solidFill>
@@ -5780,13 +7394,13 @@
       </p:sp>
       <p:sp>
         <p:nvSpPr>
-          <p:cNvPr id="9" name="TextBox 8"/>
+          <p:cNvPr id="14" name="TextBox 13"/>
           <p:cNvSpPr txBox="1"/>
           <p:nvPr/>
         </p:nvSpPr>
         <p:spPr>
           <a:xfrm>
-            <a:off x="3200400" y="3017520"/>
+            <a:off x="3200400" y="3566160"/>
             <a:ext cx="2468880" cy="640080"/>
           </a:xfrm>
           <a:prstGeom prst="rect">
@@ -5802,7 +7416,7 @@
           <a:p>
             <a:pPr algn="l"/>
             <a:r>
-              <a:rPr sz="2600" b="1">
+              <a:rPr sz="2600" b="1" i="0">
                 <a:solidFill>
                   <a:srgbClr val="FFFFFF"/>
                 </a:solidFill>
@@ -5815,13 +7429,13 @@
       </p:sp>
       <p:sp>
         <p:nvSpPr>
-          <p:cNvPr id="10" name="TextBox 9"/>
+          <p:cNvPr id="15" name="TextBox 14"/>
           <p:cNvSpPr txBox="1"/>
           <p:nvPr/>
         </p:nvSpPr>
         <p:spPr>
           <a:xfrm>
-            <a:off x="3200400" y="3611880"/>
+            <a:off x="3200400" y="4160520"/>
             <a:ext cx="2468880" cy="822960"/>
           </a:xfrm>
           <a:prstGeom prst="rect">
@@ -5835,9 +7449,8 @@
           </a:bodyPr>
           <a:lstStyle/>
           <a:p>
-            <a:pPr algn="l"/>
-            <a:r>
-              <a:rPr sz="1200" b="0">
+            <a:r>
+              <a:rPr sz="1200">
                 <a:solidFill>
                   <a:srgbClr val="9FB0AE"/>
                 </a:solidFill>
@@ -5850,13 +7463,13 @@
       </p:sp>
       <p:sp>
         <p:nvSpPr>
-          <p:cNvPr id="11" name="TextBox 10"/>
+          <p:cNvPr id="16" name="TextBox 15"/>
           <p:cNvSpPr txBox="1"/>
           <p:nvPr/>
         </p:nvSpPr>
         <p:spPr>
           <a:xfrm>
-            <a:off x="5852159" y="3017520"/>
+            <a:off x="5852159" y="3566160"/>
             <a:ext cx="2468880" cy="640080"/>
           </a:xfrm>
           <a:prstGeom prst="rect">
@@ -5872,7 +7485,7 @@
           <a:p>
             <a:pPr algn="l"/>
             <a:r>
-              <a:rPr sz="2600" b="1">
+              <a:rPr sz="2600" b="1" i="0">
                 <a:solidFill>
                   <a:srgbClr val="FFFFFF"/>
                 </a:solidFill>
@@ -5885,13 +7498,13 @@
       </p:sp>
       <p:sp>
         <p:nvSpPr>
-          <p:cNvPr id="12" name="TextBox 11"/>
+          <p:cNvPr id="17" name="TextBox 16"/>
           <p:cNvSpPr txBox="1"/>
           <p:nvPr/>
         </p:nvSpPr>
         <p:spPr>
           <a:xfrm>
-            <a:off x="5852159" y="3611880"/>
+            <a:off x="5852159" y="4160520"/>
             <a:ext cx="2468880" cy="822960"/>
           </a:xfrm>
           <a:prstGeom prst="rect">
@@ -5905,9 +7518,8 @@
           </a:bodyPr>
           <a:lstStyle/>
           <a:p>
-            <a:pPr algn="l"/>
-            <a:r>
-              <a:rPr sz="1200" b="0">
+            <a:r>
+              <a:rPr sz="1200">
                 <a:solidFill>
                   <a:srgbClr val="9FB0AE"/>
                 </a:solidFill>
@@ -5920,13 +7532,13 @@
       </p:sp>
       <p:sp>
         <p:nvSpPr>
-          <p:cNvPr id="13" name="TextBox 12"/>
+          <p:cNvPr id="18" name="TextBox 17"/>
           <p:cNvSpPr txBox="1"/>
           <p:nvPr/>
         </p:nvSpPr>
         <p:spPr>
           <a:xfrm>
-            <a:off x="8503919" y="3017520"/>
+            <a:off x="8503919" y="3566160"/>
             <a:ext cx="2468880" cy="640080"/>
           </a:xfrm>
           <a:prstGeom prst="rect">
@@ -5942,7 +7554,7 @@
           <a:p>
             <a:pPr algn="l"/>
             <a:r>
-              <a:rPr sz="2600" b="1">
+              <a:rPr sz="2600" b="1" i="0">
                 <a:solidFill>
                   <a:srgbClr val="FFFFFF"/>
                 </a:solidFill>
@@ -5955,13 +7567,13 @@
       </p:sp>
       <p:sp>
         <p:nvSpPr>
-          <p:cNvPr id="14" name="TextBox 13"/>
+          <p:cNvPr id="19" name="TextBox 18"/>
           <p:cNvSpPr txBox="1"/>
           <p:nvPr/>
         </p:nvSpPr>
         <p:spPr>
           <a:xfrm>
-            <a:off x="8503919" y="3611880"/>
+            <a:off x="8503919" y="4160520"/>
             <a:ext cx="2468880" cy="822960"/>
           </a:xfrm>
           <a:prstGeom prst="rect">
@@ -5975,9 +7587,8 @@
           </a:bodyPr>
           <a:lstStyle/>
           <a:p>
-            <a:pPr algn="l"/>
-            <a:r>
-              <a:rPr sz="1200" b="0">
+            <a:r>
+              <a:rPr sz="1200">
                 <a:solidFill>
                   <a:srgbClr val="9FB0AE"/>
                 </a:solidFill>
@@ -5990,17 +7601,19 @@
       </p:sp>
       <p:sp>
         <p:nvSpPr>
-          <p:cNvPr id="15" name="Rounded Rectangle 14"/>
+          <p:cNvPr id="20" name="Rounded Rectangle 19"/>
           <p:cNvSpPr/>
           <p:nvPr/>
         </p:nvSpPr>
         <p:spPr>
           <a:xfrm>
-            <a:off x="548640" y="4663440"/>
-            <a:ext cx="9601200" cy="1005840"/>
+            <a:off x="548640" y="5257800"/>
+            <a:ext cx="9875520" cy="1051560"/>
           </a:xfrm>
           <a:prstGeom prst="roundRect">
-            <a:avLst/>
+            <a:avLst>
+              <a:gd name="adj" fmla="val 8000"/>
+            </a:avLst>
           </a:prstGeom>
           <a:solidFill>
             <a:srgbClr val="162A47"/>
@@ -6010,6 +7623,7 @@
               <a:srgbClr val="273C5C"/>
             </a:solidFill>
           </a:ln>
+          <a:effectLst/>
         </p:spPr>
         <p:style>
           <a:lnRef idx="1">
@@ -6043,13 +7657,48 @@
           <a:p>
             <a:pPr algn="ctr"/>
             <a:r>
-              <a:rPr sz="1500">
+              <a:rPr sz="1450">
                 <a:solidFill>
                   <a:srgbClr val="9FB0AE"/>
                 </a:solidFill>
                 <a:latin typeface="Calibri"/>
               </a:rPr>
               <a:t>guillermonieto.2003@gmail.com   ·   WhatsApp +57 313 389 8628</a:t>
+            </a:r>
+          </a:p>
+        </p:txBody>
+      </p:sp>
+      <p:sp>
+        <p:nvSpPr>
+          <p:cNvPr id="21" name="TextBox 20"/>
+          <p:cNvSpPr txBox="1"/>
+          <p:nvPr/>
+        </p:nvSpPr>
+        <p:spPr>
+          <a:xfrm>
+            <a:off x="11247120" y="6446520"/>
+            <a:ext cx="731520" cy="320040"/>
+          </a:xfrm>
+          <a:prstGeom prst="rect">
+            <a:avLst/>
+          </a:prstGeom>
+          <a:noFill/>
+        </p:spPr>
+        <p:txBody>
+          <a:bodyPr wrap="square">
+            <a:spAutoFit/>
+          </a:bodyPr>
+          <a:lstStyle/>
+          <a:p>
+            <a:pPr algn="r"/>
+            <a:r>
+              <a:rPr sz="1100" b="0" i="0">
+                <a:solidFill>
+                  <a:srgbClr val="9FB0AE"/>
+                </a:solidFill>
+                <a:latin typeface="Calibri"/>
+              </a:rPr>
+              <a:t>7/7</a:t>
             </a:r>
           </a:p>
         </p:txBody>

</xml_diff>